<commit_message>
Add P&L + update deck + gitignore
</commit_message>
<xml_diff>
--- a/Ipsen.pptx
+++ b/Ipsen.pptx
@@ -3573,7 +3573,23 @@
                   <a:srgbClr val="163B5A"/>
                 </a:solidFill>
               </a:rPr>
-              <a:t>Oncology is the group cash cow, drives revenue while allow the emergence of neuroscience and rare diseases products</a:t>
+              <a:t>Oncology is the group cash cow, drives revenue while </a:t>
+            </a:r>
+            <a:r>
+              <a:rPr lang="en-AU" sz="1400" dirty="0" err="1">
+                <a:solidFill>
+                  <a:srgbClr val="163B5A"/>
+                </a:solidFill>
+              </a:rPr>
+              <a:t>fueling</a:t>
+            </a:r>
+            <a:r>
+              <a:rPr lang="en-AU" sz="1400" dirty="0">
+                <a:solidFill>
+                  <a:srgbClr val="163B5A"/>
+                </a:solidFill>
+              </a:rPr>
+              <a:t> the emergence of neuroscience and rare diseases products</a:t>
             </a:r>
           </a:p>
         </p:txBody>
@@ -3683,8 +3699,8 @@
         </p:nvSpPr>
         <p:spPr>
           <a:xfrm>
-            <a:off x="451104" y="1608530"/>
-            <a:ext cx="6336698" cy="2677656"/>
+            <a:off x="451104" y="1534679"/>
+            <a:ext cx="4500275" cy="2862322"/>
           </a:xfrm>
           <a:prstGeom prst="rect">
             <a:avLst/>
@@ -3772,6 +3788,37 @@
               <a:buChar char="•"/>
             </a:pPr>
             <a:r>
+              <a:rPr lang="en-GB" sz="1200" b="1" dirty="0"/>
+              <a:t>Controlling shareholder</a:t>
+            </a:r>
+            <a:r>
+              <a:rPr lang="en-GB" sz="1200" dirty="0"/>
+              <a:t>: </a:t>
+            </a:r>
+            <a:r>
+              <a:rPr lang="en-GB" sz="1200" dirty="0" err="1"/>
+              <a:t>Beaufour</a:t>
+            </a:r>
+            <a:r>
+              <a:rPr lang="en-GB" sz="1200" dirty="0"/>
+              <a:t> family (~57% via </a:t>
+            </a:r>
+            <a:r>
+              <a:rPr lang="en-GB" sz="1200" dirty="0" err="1"/>
+              <a:t>Mayroy</a:t>
+            </a:r>
+            <a:r>
+              <a:rPr lang="en-GB" sz="1200" dirty="0"/>
+              <a:t>)</a:t>
+            </a:r>
+            <a:endParaRPr lang="en-FR" sz="1200" dirty="0"/>
+          </a:p>
+          <a:p>
+            <a:pPr marL="285750" indent="-285750">
+              <a:buFont typeface="Arial" panose="020B0604020202020204" pitchFamily="34" charset="0"/>
+              <a:buChar char="•"/>
+            </a:pPr>
+            <a:r>
               <a:rPr lang="en-FR" sz="1200" b="1" dirty="0"/>
               <a:t>Geography sales 2025</a:t>
             </a:r>
@@ -3823,15 +3870,21 @@
             </a:r>
           </a:p>
           <a:p>
+            <a:pPr marL="742950" lvl="1" indent="-285750">
+              <a:buFont typeface="Arial" panose="020B0604020202020204" pitchFamily="34" charset="0"/>
+              <a:buChar char="•"/>
+            </a:pPr>
+            <a:endParaRPr lang="en-FR" sz="1200" dirty="0"/>
+          </a:p>
+          <a:p>
             <a:pPr marL="285750" indent="-285750">
               <a:buFont typeface="Arial" panose="020B0604020202020204" pitchFamily="34" charset="0"/>
               <a:buChar char="•"/>
             </a:pPr>
             <a:r>
-              <a:rPr lang="en-FR" sz="1200" b="1" dirty="0"/>
-              <a:t>Key takeaways</a:t>
-            </a:r>
-            <a:endParaRPr lang="en-FR" sz="1200" dirty="0"/>
+              <a:rPr lang="en-GB" sz="1200" b="1" dirty="0"/>
+              <a:t>Financial highlights:</a:t>
+            </a:r>
           </a:p>
           <a:p>
             <a:pPr marL="742950" lvl="1" indent="-285750">
@@ -3839,54 +3892,10 @@
               <a:buChar char="•"/>
             </a:pPr>
             <a:r>
-              <a:rPr lang="en-FR" sz="1200" b="1" dirty="0"/>
-              <a:t>Oncology as the group’s economic core</a:t>
-            </a:r>
-            <a:r>
-              <a:rPr lang="en-FR" sz="1200" dirty="0"/>
-              <a:t> (largest TA &amp; main revenue contributor)</a:t>
-            </a:r>
-          </a:p>
-          <a:p>
-            <a:pPr marL="742950" lvl="1" indent="-285750">
-              <a:buFont typeface="Arial" panose="020B0604020202020204" pitchFamily="34" charset="0"/>
-              <a:buChar char="•"/>
-            </a:pPr>
-            <a:r>
-              <a:rPr lang="en-GB" sz="1200" b="1" dirty="0"/>
-              <a:t>Neurosciences: </a:t>
-            </a:r>
-            <a:r>
-              <a:rPr lang="en-GB" sz="1200" i="1" dirty="0"/>
-              <a:t>Dysport</a:t>
-            </a:r>
-            <a:r>
               <a:rPr lang="en-GB" sz="1200" dirty="0"/>
-              <a:t>-led business, with </a:t>
-            </a:r>
-            <a:r>
-              <a:rPr lang="en-GB" sz="1200" i="1" dirty="0" err="1"/>
-              <a:t>corabotase</a:t>
-            </a:r>
-            <a:r>
-              <a:rPr lang="en-GB" sz="1200" dirty="0"/>
-              <a:t> as next-generation growth relay</a:t>
-            </a:r>
-          </a:p>
-          <a:p>
-            <a:pPr marL="742950" lvl="1" indent="-285750">
-              <a:buFont typeface="Arial" panose="020B0604020202020204" pitchFamily="34" charset="0"/>
-              <a:buChar char="•"/>
-            </a:pPr>
-            <a:r>
-              <a:rPr lang="en-FR" sz="1200" b="1" dirty="0"/>
-              <a:t>Rare diseases </a:t>
-            </a:r>
-            <a:r>
-              <a:rPr lang="en-FR" sz="1200" dirty="0"/>
-              <a:t>as portfolio diversification</a:t>
-            </a:r>
-            <a:endParaRPr lang="en-AU" sz="1200" dirty="0"/>
+              <a:t>Net cash position: +€560M (FY25): strong bolt-on M&amp;A firepower</a:t>
+            </a:r>
+            <a:endParaRPr lang="en-FR" sz="1200" dirty="0"/>
           </a:p>
         </p:txBody>
       </p:sp>
@@ -3940,42 +3949,42 @@
           <p:nvPr>
             <p:extLst>
               <p:ext uri="{D42A27DB-BD31-4B8C-83A1-F6EECF244321}">
-                <p14:modId xmlns:p14="http://schemas.microsoft.com/office/powerpoint/2010/main" val="1178206680"/>
+                <p14:modId xmlns:p14="http://schemas.microsoft.com/office/powerpoint/2010/main" val="2648005757"/>
               </p:ext>
             </p:extLst>
           </p:nvPr>
         </p:nvGraphicFramePr>
         <p:xfrm>
-          <a:off x="6874867" y="2112944"/>
-          <a:ext cx="5232065" cy="3720465"/>
+          <a:off x="6235431" y="1608530"/>
+          <a:ext cx="5871503" cy="3221355"/>
         </p:xfrm>
         <a:graphic>
           <a:graphicData uri="http://schemas.openxmlformats.org/drawingml/2006/table">
             <a:tbl>
               <a:tblPr/>
               <a:tblGrid>
-                <a:gridCol w="2685103">
+                <a:gridCol w="3013263">
                   <a:extLst>
                     <a:ext uri="{9D8B030D-6E8A-4147-A177-3AD203B41FA5}">
                       <a16:colId xmlns:a16="http://schemas.microsoft.com/office/drawing/2014/main" val="1086495563"/>
                     </a:ext>
                   </a:extLst>
                 </a:gridCol>
-                <a:gridCol w="966982">
+                <a:gridCol w="1085162">
                   <a:extLst>
                     <a:ext uri="{9D8B030D-6E8A-4147-A177-3AD203B41FA5}">
                       <a16:colId xmlns:a16="http://schemas.microsoft.com/office/drawing/2014/main" val="3095386841"/>
                     </a:ext>
                   </a:extLst>
                 </a:gridCol>
-                <a:gridCol w="966982">
+                <a:gridCol w="1085162">
                   <a:extLst>
                     <a:ext uri="{9D8B030D-6E8A-4147-A177-3AD203B41FA5}">
                       <a16:colId xmlns:a16="http://schemas.microsoft.com/office/drawing/2014/main" val="2581013858"/>
                     </a:ext>
                   </a:extLst>
                 </a:gridCol>
-                <a:gridCol w="612998">
+                <a:gridCol w="687916">
                   <a:extLst>
                     <a:ext uri="{9D8B030D-6E8A-4147-A177-3AD203B41FA5}">
                       <a16:colId xmlns:a16="http://schemas.microsoft.com/office/drawing/2014/main" val="1447243760"/>
@@ -5163,7 +5172,7 @@
                         <a:buNone/>
                       </a:pPr>
                       <a:r>
-                        <a:rPr lang="en-FR" sz="1050" b="0" i="0" u="none" strike="noStrike">
+                        <a:rPr lang="en-FR" sz="1050" b="0" i="0" u="none" strike="noStrike" dirty="0">
                           <a:effectLst/>
                           <a:latin typeface="Arial" panose="020B0604020202020204" pitchFamily="34" charset="0"/>
                         </a:rPr>
@@ -5196,7 +5205,7 @@
                         <a:buNone/>
                       </a:pPr>
                       <a:r>
-                        <a:rPr lang="en-FR" sz="1050" b="0" i="0" u="none" strike="noStrike">
+                        <a:rPr lang="en-FR" sz="1050" b="0" i="0" u="none" strike="noStrike" dirty="0">
                           <a:effectLst/>
                           <a:latin typeface="Arial" panose="020B0604020202020204" pitchFamily="34" charset="0"/>
                         </a:rPr>
@@ -6708,7 +6717,7 @@
                         <a:buNone/>
                       </a:pPr>
                       <a:r>
-                        <a:rPr lang="en-FR" sz="1050" b="1" i="0" u="none" strike="noStrike">
+                        <a:rPr lang="en-FR" sz="1050" b="1" i="0" u="none" strike="noStrike" dirty="0">
                           <a:effectLst/>
                           <a:latin typeface="Arial" panose="020B0604020202020204" pitchFamily="34" charset="0"/>
                         </a:rPr>
@@ -6737,288 +6746,6 @@
                 <a:extLst>
                   <a:ext uri="{0D108BD9-81ED-4DB2-BD59-A6C34878D82A}">
                     <a16:rowId xmlns:a16="http://schemas.microsoft.com/office/drawing/2014/main" val="639691924"/>
-                  </a:ext>
-                </a:extLst>
-              </a:tr>
-              <a:tr h="109474">
-                <a:tc>
-                  <a:txBody>
-                    <a:bodyPr/>
-                    <a:lstStyle/>
-                    <a:p>
-                      <a:pPr algn="l" fontAlgn="b">
-                        <a:buNone/>
-                      </a:pPr>
-                      <a:r>
-                        <a:rPr lang="en-FR" sz="1050" b="1" i="0" u="none" strike="noStrike">
-                          <a:effectLst/>
-                          <a:latin typeface="Arial" panose="020B0604020202020204" pitchFamily="34" charset="0"/>
-                        </a:rPr>
-                        <a:t>Basic Earnings Per Share (in euros)</a:t>
-                      </a:r>
-                    </a:p>
-                  </a:txBody>
-                  <a:tcPr marL="85725" marR="9525" marT="9525" marB="0" anchor="b">
-                    <a:lnL>
-                      <a:noFill/>
-                    </a:lnL>
-                    <a:lnR>
-                      <a:noFill/>
-                    </a:lnR>
-                    <a:lnT>
-                      <a:noFill/>
-                    </a:lnT>
-                    <a:lnB>
-                      <a:noFill/>
-                    </a:lnB>
-                    <a:noFill/>
-                  </a:tcPr>
-                </a:tc>
-                <a:tc>
-                  <a:txBody>
-                    <a:bodyPr/>
-                    <a:lstStyle/>
-                    <a:p>
-                      <a:pPr algn="l" fontAlgn="b">
-                        <a:buNone/>
-                      </a:pPr>
-                      <a:r>
-                        <a:rPr lang="en-FR" sz="1050" b="1" i="0" u="none" strike="noStrike">
-                          <a:effectLst/>
-                          <a:latin typeface="Arial" panose="020B0604020202020204" pitchFamily="34" charset="0"/>
-                        </a:rPr>
-                        <a:t> $                    5 </a:t>
-                      </a:r>
-                    </a:p>
-                  </a:txBody>
-                  <a:tcPr marL="9525" marR="9525" marT="9525" marB="0" anchor="b">
-                    <a:lnL>
-                      <a:noFill/>
-                    </a:lnL>
-                    <a:lnR>
-                      <a:noFill/>
-                    </a:lnR>
-                    <a:lnT>
-                      <a:noFill/>
-                    </a:lnT>
-                    <a:lnB>
-                      <a:noFill/>
-                    </a:lnB>
-                    <a:noFill/>
-                  </a:tcPr>
-                </a:tc>
-                <a:tc>
-                  <a:txBody>
-                    <a:bodyPr/>
-                    <a:lstStyle/>
-                    <a:p>
-                      <a:pPr algn="l" fontAlgn="b">
-                        <a:buNone/>
-                      </a:pPr>
-                      <a:r>
-                        <a:rPr lang="en-FR" sz="1050" b="1" i="0" u="none" strike="noStrike">
-                          <a:effectLst/>
-                          <a:latin typeface="Arial" panose="020B0604020202020204" pitchFamily="34" charset="0"/>
-                        </a:rPr>
-                        <a:t> $                    4 </a:t>
-                      </a:r>
-                    </a:p>
-                  </a:txBody>
-                  <a:tcPr marL="9525" marR="9525" marT="9525" marB="0" anchor="b">
-                    <a:lnL>
-                      <a:noFill/>
-                    </a:lnL>
-                    <a:lnR>
-                      <a:noFill/>
-                    </a:lnR>
-                    <a:lnT>
-                      <a:noFill/>
-                    </a:lnT>
-                    <a:lnB>
-                      <a:noFill/>
-                    </a:lnB>
-                    <a:noFill/>
-                  </a:tcPr>
-                </a:tc>
-                <a:tc>
-                  <a:txBody>
-                    <a:bodyPr/>
-                    <a:lstStyle/>
-                    <a:p>
-                      <a:pPr algn="ctr" fontAlgn="b">
-                        <a:buNone/>
-                      </a:pPr>
-                      <a:r>
-                        <a:rPr lang="en-FR" sz="1050" b="0" i="0" u="none" strike="noStrike">
-                          <a:effectLst/>
-                          <a:latin typeface="Arial" panose="020B0604020202020204" pitchFamily="34" charset="0"/>
-                        </a:rPr>
-                        <a:t> </a:t>
-                      </a:r>
-                    </a:p>
-                  </a:txBody>
-                  <a:tcPr marL="9525" marR="9525" marT="9525" marB="0" anchor="b">
-                    <a:lnL>
-                      <a:noFill/>
-                    </a:lnL>
-                    <a:lnR>
-                      <a:noFill/>
-                    </a:lnR>
-                    <a:lnT>
-                      <a:noFill/>
-                    </a:lnT>
-                    <a:lnB>
-                      <a:noFill/>
-                    </a:lnB>
-                    <a:solidFill>
-                      <a:srgbClr val="FFFFFF"/>
-                    </a:solidFill>
-                  </a:tcPr>
-                </a:tc>
-                <a:extLst>
-                  <a:ext uri="{0D108BD9-81ED-4DB2-BD59-A6C34878D82A}">
-                    <a16:rowId xmlns:a16="http://schemas.microsoft.com/office/drawing/2014/main" val="2364795604"/>
-                  </a:ext>
-                </a:extLst>
-              </a:tr>
-              <a:tr h="109474">
-                <a:tc>
-                  <a:txBody>
-                    <a:bodyPr/>
-                    <a:lstStyle/>
-                    <a:p>
-                      <a:pPr algn="l" fontAlgn="b">
-                        <a:buNone/>
-                      </a:pPr>
-                      <a:r>
-                        <a:rPr lang="en-FR" sz="1050" b="1" i="0" u="none" strike="noStrike">
-                          <a:effectLst/>
-                          <a:latin typeface="Arial" panose="020B0604020202020204" pitchFamily="34" charset="0"/>
-                        </a:rPr>
-                        <a:t>Diluted Earnings Per Share (in euros)</a:t>
-                      </a:r>
-                    </a:p>
-                  </a:txBody>
-                  <a:tcPr marL="85725" marR="9525" marT="9525" marB="0" anchor="b">
-                    <a:lnL>
-                      <a:noFill/>
-                    </a:lnL>
-                    <a:lnR>
-                      <a:noFill/>
-                    </a:lnR>
-                    <a:lnT>
-                      <a:noFill/>
-                    </a:lnT>
-                    <a:lnB>
-                      <a:noFill/>
-                    </a:lnB>
-                    <a:noFill/>
-                  </a:tcPr>
-                </a:tc>
-                <a:tc>
-                  <a:txBody>
-                    <a:bodyPr/>
-                    <a:lstStyle/>
-                    <a:p>
-                      <a:pPr algn="l" fontAlgn="b">
-                        <a:buNone/>
-                      </a:pPr>
-                      <a:r>
-                        <a:rPr lang="en-FR" sz="1050" b="1" i="0" u="none" strike="noStrike">
-                          <a:effectLst/>
-                          <a:latin typeface="Arial" panose="020B0604020202020204" pitchFamily="34" charset="0"/>
-                        </a:rPr>
-                        <a:t> $                    5 </a:t>
-                      </a:r>
-                    </a:p>
-                  </a:txBody>
-                  <a:tcPr marL="9525" marR="9525" marT="9525" marB="0" anchor="b">
-                    <a:lnL>
-                      <a:noFill/>
-                    </a:lnL>
-                    <a:lnR>
-                      <a:noFill/>
-                    </a:lnR>
-                    <a:lnT>
-                      <a:noFill/>
-                    </a:lnT>
-                    <a:lnB>
-                      <a:noFill/>
-                    </a:lnB>
-                    <a:noFill/>
-                  </a:tcPr>
-                </a:tc>
-                <a:tc>
-                  <a:txBody>
-                    <a:bodyPr/>
-                    <a:lstStyle/>
-                    <a:p>
-                      <a:pPr algn="l" fontAlgn="b">
-                        <a:buNone/>
-                      </a:pPr>
-                      <a:r>
-                        <a:rPr lang="en-FR" sz="1050" b="1" i="0" u="none" strike="noStrike">
-                          <a:effectLst/>
-                          <a:latin typeface="Arial" panose="020B0604020202020204" pitchFamily="34" charset="0"/>
-                        </a:rPr>
-                        <a:t> $                    4 </a:t>
-                      </a:r>
-                    </a:p>
-                  </a:txBody>
-                  <a:tcPr marL="9525" marR="9525" marT="9525" marB="0" anchor="b">
-                    <a:lnL>
-                      <a:noFill/>
-                    </a:lnL>
-                    <a:lnR>
-                      <a:noFill/>
-                    </a:lnR>
-                    <a:lnT>
-                      <a:noFill/>
-                    </a:lnT>
-                    <a:lnB>
-                      <a:noFill/>
-                    </a:lnB>
-                    <a:noFill/>
-                  </a:tcPr>
-                </a:tc>
-                <a:tc>
-                  <a:txBody>
-                    <a:bodyPr/>
-                    <a:lstStyle/>
-                    <a:p>
-                      <a:pPr algn="ctr" fontAlgn="b">
-                        <a:buNone/>
-                      </a:pPr>
-                      <a:r>
-                        <a:rPr lang="en-FR" sz="1050" b="0" i="0" u="none" strike="noStrike" dirty="0">
-                          <a:effectLst/>
-                          <a:latin typeface="Arial" panose="020B0604020202020204" pitchFamily="34" charset="0"/>
-                        </a:rPr>
-                        <a:t> </a:t>
-                      </a:r>
-                    </a:p>
-                  </a:txBody>
-                  <a:tcPr marL="9525" marR="9525" marT="9525" marB="0" anchor="b">
-                    <a:lnL>
-                      <a:noFill/>
-                    </a:lnL>
-                    <a:lnR>
-                      <a:noFill/>
-                    </a:lnR>
-                    <a:lnT>
-                      <a:noFill/>
-                    </a:lnT>
-                    <a:lnB>
-                      <a:noFill/>
-                    </a:lnB>
-                    <a:solidFill>
-                      <a:srgbClr val="FFFFFF"/>
-                    </a:solidFill>
-                  </a:tcPr>
-                </a:tc>
-                <a:extLst>
-                  <a:ext uri="{0D108BD9-81ED-4DB2-BD59-A6C34878D82A}">
-                    <a16:rowId xmlns:a16="http://schemas.microsoft.com/office/drawing/2014/main" val="640954918"/>
                   </a:ext>
                 </a:extLst>
               </a:tr>
@@ -7040,7 +6767,7 @@
         </p:nvSpPr>
         <p:spPr>
           <a:xfrm>
-            <a:off x="6863648" y="1912951"/>
+            <a:off x="6261845" y="1456815"/>
             <a:ext cx="2900922" cy="45719"/>
           </a:xfrm>
           <a:prstGeom prst="rect">
@@ -7092,7 +6819,7 @@
         </p:nvSpPr>
         <p:spPr>
           <a:xfrm>
-            <a:off x="6787802" y="1566478"/>
+            <a:off x="6185999" y="1110342"/>
             <a:ext cx="1265475" cy="369332"/>
           </a:xfrm>
           <a:prstGeom prst="rect">
@@ -7131,7 +6858,7 @@
         </p:nvSpPr>
         <p:spPr>
           <a:xfrm>
-            <a:off x="526950" y="4632659"/>
+            <a:off x="526950" y="4992464"/>
             <a:ext cx="2900922" cy="45719"/>
           </a:xfrm>
           <a:prstGeom prst="rect">
@@ -7183,7 +6910,7 @@
         </p:nvSpPr>
         <p:spPr>
           <a:xfrm>
-            <a:off x="451104" y="4286186"/>
+            <a:off x="451104" y="4645991"/>
             <a:ext cx="1133324" cy="369332"/>
           </a:xfrm>
           <a:prstGeom prst="rect">
@@ -7223,14 +6950,14 @@
           <p:nvPr>
             <p:extLst>
               <p:ext uri="{D42A27DB-BD31-4B8C-83A1-F6EECF244321}">
-                <p14:modId xmlns:p14="http://schemas.microsoft.com/office/powerpoint/2010/main" val="54218955"/>
+                <p14:modId xmlns:p14="http://schemas.microsoft.com/office/powerpoint/2010/main" val="561119692"/>
               </p:ext>
             </p:extLst>
           </p:nvPr>
         </p:nvGraphicFramePr>
         <p:xfrm>
-          <a:off x="526950" y="4765380"/>
-          <a:ext cx="6118293" cy="1964554"/>
+          <a:off x="526950" y="5166831"/>
+          <a:ext cx="9898900" cy="1582479"/>
         </p:xfrm>
         <a:graphic>
           <a:graphicData uri="http://schemas.openxmlformats.org/drawingml/2006/table">
@@ -7239,42 +6966,49 @@
                 <a:tableStyleId>{6E25E649-3F16-4E02-A733-19D2CDBF48F0}</a:tableStyleId>
               </a:tblPr>
               <a:tblGrid>
-                <a:gridCol w="1247529">
+                <a:gridCol w="848058">
                   <a:extLst>
                     <a:ext uri="{9D8B030D-6E8A-4147-A177-3AD203B41FA5}">
                       <a16:colId xmlns:a16="http://schemas.microsoft.com/office/drawing/2014/main" val="1755445364"/>
                     </a:ext>
                   </a:extLst>
                 </a:gridCol>
-                <a:gridCol w="986828">
+                <a:gridCol w="1174595">
                   <a:extLst>
                     <a:ext uri="{9D8B030D-6E8A-4147-A177-3AD203B41FA5}">
                       <a16:colId xmlns:a16="http://schemas.microsoft.com/office/drawing/2014/main" val="1116672927"/>
                     </a:ext>
                   </a:extLst>
                 </a:gridCol>
-                <a:gridCol w="959667">
+                <a:gridCol w="1865971">
+                  <a:extLst>
+                    <a:ext uri="{9D8B030D-6E8A-4147-A177-3AD203B41FA5}">
+                      <a16:colId xmlns:a16="http://schemas.microsoft.com/office/drawing/2014/main" val="356679497"/>
+                    </a:ext>
+                  </a:extLst>
+                </a:gridCol>
+                <a:gridCol w="3113088">
+                  <a:extLst>
+                    <a:ext uri="{9D8B030D-6E8A-4147-A177-3AD203B41FA5}">
+                      <a16:colId xmlns:a16="http://schemas.microsoft.com/office/drawing/2014/main" val="853823028"/>
+                    </a:ext>
+                  </a:extLst>
+                </a:gridCol>
+                <a:gridCol w="1454150">
                   <a:extLst>
                     <a:ext uri="{9D8B030D-6E8A-4147-A177-3AD203B41FA5}">
                       <a16:colId xmlns:a16="http://schemas.microsoft.com/office/drawing/2014/main" val="4258530580"/>
                     </a:ext>
                   </a:extLst>
                 </a:gridCol>
-                <a:gridCol w="1013988">
-                  <a:extLst>
-                    <a:ext uri="{9D8B030D-6E8A-4147-A177-3AD203B41FA5}">
-                      <a16:colId xmlns:a16="http://schemas.microsoft.com/office/drawing/2014/main" val="3265045297"/>
-                    </a:ext>
-                  </a:extLst>
-                </a:gridCol>
-                <a:gridCol w="876745">
+                <a:gridCol w="560388">
                   <a:extLst>
                     <a:ext uri="{9D8B030D-6E8A-4147-A177-3AD203B41FA5}">
                       <a16:colId xmlns:a16="http://schemas.microsoft.com/office/drawing/2014/main" val="4174490988"/>
                     </a:ext>
                   </a:extLst>
                 </a:gridCol>
-                <a:gridCol w="1033536">
+                <a:gridCol w="882650">
                   <a:extLst>
                     <a:ext uri="{9D8B030D-6E8A-4147-A177-3AD203B41FA5}">
                       <a16:colId xmlns:a16="http://schemas.microsoft.com/office/drawing/2014/main" val="1289759013"/>
@@ -7320,41 +7054,13 @@
                         <a:buNone/>
                       </a:pPr>
                       <a:r>
-                        <a:rPr lang="en-FR" sz="1000" b="1" u="none" strike="noStrike">
-                          <a:solidFill>
-                            <a:schemeClr val="bg1"/>
-                          </a:solidFill>
-                          <a:effectLst/>
-                        </a:rPr>
-                        <a:t>TA</a:t>
-                      </a:r>
-                      <a:endParaRPr lang="en-FR" sz="1000" b="1" i="0" u="none" strike="noStrike">
-                        <a:solidFill>
-                          <a:schemeClr val="bg1"/>
-                        </a:solidFill>
-                        <a:effectLst/>
-                        <a:latin typeface="Arial" panose="020B0604020202020204" pitchFamily="34" charset="0"/>
-                      </a:endParaRPr>
-                    </a:p>
-                  </a:txBody>
-                  <a:tcPr marL="9525" marR="9525" marT="9525" marB="0" anchor="ctr"/>
-                </a:tc>
-                <a:tc>
-                  <a:txBody>
-                    <a:bodyPr/>
-                    <a:lstStyle/>
-                    <a:p>
-                      <a:pPr algn="ctr" fontAlgn="ctr">
-                        <a:buNone/>
-                      </a:pPr>
-                      <a:r>
                         <a:rPr lang="en-FR" sz="1000" b="1" u="none" strike="noStrike" dirty="0">
                           <a:solidFill>
                             <a:schemeClr val="bg1"/>
                           </a:solidFill>
                           <a:effectLst/>
                         </a:rPr>
-                        <a:t>Rev 2025 (€M)</a:t>
+                        <a:t>TA</a:t>
                       </a:r>
                       <a:endParaRPr lang="en-FR" sz="1000" b="1" i="0" u="none" strike="noStrike" dirty="0">
                         <a:solidFill>
@@ -7376,13 +7082,57 @@
                         <a:buNone/>
                       </a:pPr>
                       <a:r>
+                        <a:rPr lang="en-FR" sz="1000" b="1" i="0" u="none" strike="noStrike" dirty="0">
+                          <a:solidFill>
+                            <a:schemeClr val="bg1"/>
+                          </a:solidFill>
+                          <a:effectLst/>
+                          <a:latin typeface="Arial" panose="020B0604020202020204" pitchFamily="34" charset="0"/>
+                        </a:rPr>
+                        <a:t>MoA</a:t>
+                      </a:r>
+                    </a:p>
+                  </a:txBody>
+                  <a:tcPr marL="9525" marR="9525" marT="9525" marB="0" anchor="ctr"/>
+                </a:tc>
+                <a:tc>
+                  <a:txBody>
+                    <a:bodyPr/>
+                    <a:lstStyle/>
+                    <a:p>
+                      <a:pPr algn="ctr" fontAlgn="ctr">
+                        <a:buNone/>
+                      </a:pPr>
+                      <a:r>
+                        <a:rPr lang="en-FR" sz="1000" b="1" i="0" u="none" strike="noStrike" dirty="0">
+                          <a:solidFill>
+                            <a:schemeClr val="bg1"/>
+                          </a:solidFill>
+                          <a:effectLst/>
+                          <a:latin typeface="Arial" panose="020B0604020202020204" pitchFamily="34" charset="0"/>
+                        </a:rPr>
+                        <a:t>Indication</a:t>
+                      </a:r>
+                    </a:p>
+                  </a:txBody>
+                  <a:tcPr marL="9525" marR="9525" marT="9525" marB="0" anchor="ctr"/>
+                </a:tc>
+                <a:tc>
+                  <a:txBody>
+                    <a:bodyPr/>
+                    <a:lstStyle/>
+                    <a:p>
+                      <a:pPr algn="ctr" fontAlgn="ctr">
+                        <a:buNone/>
+                      </a:pPr>
+                      <a:r>
                         <a:rPr lang="en-FR" sz="1000" b="1" u="none" strike="noStrike" dirty="0">
                           <a:solidFill>
                             <a:schemeClr val="bg1"/>
                           </a:solidFill>
                           <a:effectLst/>
                         </a:rPr>
-                        <a:t>Variation 2024</a:t>
+                        <a:t>Rev 2025 (€M)</a:t>
                       </a:r>
                       <a:endParaRPr lang="en-FR" sz="1000" b="1" i="0" u="none" strike="noStrike" dirty="0">
                         <a:solidFill>
@@ -7523,7 +7273,7 @@
                         <a:buNone/>
                       </a:pPr>
                       <a:r>
-                        <a:rPr lang="en-FR" sz="1000" b="0" u="none" strike="noStrike">
+                        <a:rPr lang="en-GB" sz="1000" b="0" i="0" u="none" strike="noStrike" dirty="0">
                           <a:solidFill>
                             <a:srgbClr val="000000"/>
                           </a:solidFill>
@@ -7531,9 +7281,31 @@
                           <a:latin typeface="Arial" panose="020B0604020202020204" pitchFamily="34" charset="0"/>
                           <a:cs typeface="Arial" panose="020B0604020202020204" pitchFamily="34" charset="0"/>
                         </a:rPr>
-                        <a:t> $         1 135 </a:t>
-                      </a:r>
-                      <a:endParaRPr lang="en-FR" sz="1000" b="0" i="0" u="none" strike="noStrike">
+                        <a:t>Somatostatin </a:t>
+                      </a:r>
+                      <a:r>
+                        <a:rPr lang="en-GB" sz="1000" b="0" i="0" u="none" strike="noStrike" dirty="0" err="1">
+                          <a:solidFill>
+                            <a:srgbClr val="000000"/>
+                          </a:solidFill>
+                          <a:effectLst/>
+                          <a:latin typeface="Arial" panose="020B0604020202020204" pitchFamily="34" charset="0"/>
+                          <a:cs typeface="Arial" panose="020B0604020202020204" pitchFamily="34" charset="0"/>
+                        </a:rPr>
+                        <a:t>analog</a:t>
+                      </a:r>
+                      <a:r>
+                        <a:rPr lang="en-GB" sz="1000" b="0" i="0" u="none" strike="noStrike" dirty="0">
+                          <a:solidFill>
+                            <a:srgbClr val="000000"/>
+                          </a:solidFill>
+                          <a:effectLst/>
+                          <a:latin typeface="Arial" panose="020B0604020202020204" pitchFamily="34" charset="0"/>
+                          <a:cs typeface="Arial" panose="020B0604020202020204" pitchFamily="34" charset="0"/>
+                        </a:rPr>
+                        <a:t> (SSA)</a:t>
+                      </a:r>
+                      <a:endParaRPr lang="en-FR" sz="1000" b="0" i="0" u="none" strike="noStrike" dirty="0">
                         <a:solidFill>
                           <a:srgbClr val="000000"/>
                         </a:solidFill>
@@ -7550,11 +7322,11 @@
                     <a:bodyPr/>
                     <a:lstStyle/>
                     <a:p>
-                      <a:pPr algn="ctr" fontAlgn="b">
-                        <a:buNone/>
-                      </a:pPr>
-                      <a:r>
-                        <a:rPr lang="en-FR" sz="1000" b="0" u="none" strike="noStrike">
+                      <a:pPr algn="l" fontAlgn="b">
+                        <a:buNone/>
+                      </a:pPr>
+                      <a:r>
+                        <a:rPr lang="en-GB" sz="1000" b="0" i="0" u="none" strike="noStrike" dirty="0">
                           <a:solidFill>
                             <a:srgbClr val="000000"/>
                           </a:solidFill>
@@ -7562,9 +7334,31 @@
                           <a:latin typeface="Arial" panose="020B0604020202020204" pitchFamily="34" charset="0"/>
                           <a:cs typeface="Arial" panose="020B0604020202020204" pitchFamily="34" charset="0"/>
                         </a:rPr>
-                        <a:t>4.3%</a:t>
-                      </a:r>
-                      <a:endParaRPr lang="en-FR" sz="1000" b="0" i="0" u="none" strike="noStrike">
+                        <a:t>NET (neuroendocrine </a:t>
+                      </a:r>
+                      <a:r>
+                        <a:rPr lang="en-GB" sz="1000" b="0" i="0" u="none" strike="noStrike" dirty="0" err="1">
+                          <a:solidFill>
+                            <a:srgbClr val="000000"/>
+                          </a:solidFill>
+                          <a:effectLst/>
+                          <a:latin typeface="Arial" panose="020B0604020202020204" pitchFamily="34" charset="0"/>
+                          <a:cs typeface="Arial" panose="020B0604020202020204" pitchFamily="34" charset="0"/>
+                        </a:rPr>
+                        <a:t>tumors</a:t>
+                      </a:r>
+                      <a:r>
+                        <a:rPr lang="en-GB" sz="1000" b="0" i="0" u="none" strike="noStrike" dirty="0">
+                          <a:solidFill>
+                            <a:srgbClr val="000000"/>
+                          </a:solidFill>
+                          <a:effectLst/>
+                          <a:latin typeface="Arial" panose="020B0604020202020204" pitchFamily="34" charset="0"/>
+                          <a:cs typeface="Arial" panose="020B0604020202020204" pitchFamily="34" charset="0"/>
+                        </a:rPr>
+                        <a:t>) + acromegaly</a:t>
+                      </a:r>
+                      <a:endParaRPr lang="en-FR" sz="1000" b="0" i="0" u="none" strike="noStrike" dirty="0">
                         <a:solidFill>
                           <a:srgbClr val="000000"/>
                         </a:solidFill>
@@ -7581,6 +7375,37 @@
                     <a:bodyPr/>
                     <a:lstStyle/>
                     <a:p>
+                      <a:pPr algn="l" fontAlgn="b">
+                        <a:buNone/>
+                      </a:pPr>
+                      <a:r>
+                        <a:rPr lang="en-FR" sz="1000" b="0" u="none" strike="noStrike" dirty="0">
+                          <a:solidFill>
+                            <a:srgbClr val="000000"/>
+                          </a:solidFill>
+                          <a:effectLst/>
+                          <a:latin typeface="Arial" panose="020B0604020202020204" pitchFamily="34" charset="0"/>
+                          <a:cs typeface="Arial" panose="020B0604020202020204" pitchFamily="34" charset="0"/>
+                        </a:rPr>
+                        <a:t> $         1 135 (+4.3%) </a:t>
+                      </a:r>
+                      <a:endParaRPr lang="en-FR" sz="1000" b="0" i="0" u="none" strike="noStrike" dirty="0">
+                        <a:solidFill>
+                          <a:srgbClr val="000000"/>
+                        </a:solidFill>
+                        <a:effectLst/>
+                        <a:latin typeface="Arial" panose="020B0604020202020204" pitchFamily="34" charset="0"/>
+                        <a:cs typeface="Arial" panose="020B0604020202020204" pitchFamily="34" charset="0"/>
+                      </a:endParaRPr>
+                    </a:p>
+                  </a:txBody>
+                  <a:tcPr marL="9525" marR="9525" marT="9525" marB="0" anchor="ctr"/>
+                </a:tc>
+                <a:tc>
+                  <a:txBody>
+                    <a:bodyPr/>
+                    <a:lstStyle/>
+                    <a:p>
                       <a:pPr algn="ctr" fontAlgn="b">
                         <a:buNone/>
                       </a:pPr>
@@ -7593,7 +7418,7 @@
                           <a:latin typeface="Arial" panose="020B0604020202020204" pitchFamily="34" charset="0"/>
                           <a:cs typeface="Arial" panose="020B0604020202020204" pitchFamily="34" charset="0"/>
                         </a:rPr>
-                        <a:t>Peptid</a:t>
+                        <a:t>Peptide</a:t>
                       </a:r>
                     </a:p>
                   </a:txBody>
@@ -7660,7 +7485,7 @@
                           <a:latin typeface="Arial" panose="020B0604020202020204" pitchFamily="34" charset="0"/>
                           <a:cs typeface="Arial" panose="020B0604020202020204" pitchFamily="34" charset="0"/>
                         </a:rPr>
-                        <a:t>Cabometyx</a:t>
+                        <a:t>Cabometyx*</a:t>
                       </a:r>
                       <a:endParaRPr lang="en-FR" sz="1000" b="0" i="0" u="none" strike="noStrike" dirty="0">
                         <a:solidFill>
@@ -7714,7 +7539,7 @@
                         <a:buNone/>
                       </a:pPr>
                       <a:r>
-                        <a:rPr lang="en-FR" sz="1000" b="0" u="none" strike="noStrike" dirty="0">
+                        <a:rPr lang="en-GB" sz="1000" b="0" i="0" u="none" strike="noStrike" dirty="0">
                           <a:solidFill>
                             <a:srgbClr val="000000"/>
                           </a:solidFill>
@@ -7722,7 +7547,7 @@
                           <a:latin typeface="Arial" panose="020B0604020202020204" pitchFamily="34" charset="0"/>
                           <a:cs typeface="Arial" panose="020B0604020202020204" pitchFamily="34" charset="0"/>
                         </a:rPr>
-                        <a:t> $            613 </a:t>
+                        <a:t>Multi-TKI (VEGFR/MET/AXL)</a:t>
                       </a:r>
                       <a:endParaRPr lang="en-FR" sz="1000" b="0" i="0" u="none" strike="noStrike" dirty="0">
                         <a:solidFill>
@@ -7741,11 +7566,11 @@
                     <a:bodyPr/>
                     <a:lstStyle/>
                     <a:p>
-                      <a:pPr algn="ctr" fontAlgn="b">
-                        <a:buNone/>
-                      </a:pPr>
-                      <a:r>
-                        <a:rPr lang="en-FR" sz="1000" b="0" u="none" strike="noStrike" dirty="0">
+                      <a:pPr algn="l" fontAlgn="b">
+                        <a:buNone/>
+                      </a:pPr>
+                      <a:r>
+                        <a:rPr lang="en-GB" sz="1000" b="0" i="0" u="none" strike="noStrike" dirty="0">
                           <a:solidFill>
                             <a:srgbClr val="000000"/>
                           </a:solidFill>
@@ -7753,7 +7578,7 @@
                           <a:latin typeface="Arial" panose="020B0604020202020204" pitchFamily="34" charset="0"/>
                           <a:cs typeface="Arial" panose="020B0604020202020204" pitchFamily="34" charset="0"/>
                         </a:rPr>
-                        <a:t>5.1%</a:t>
+                        <a:t>RCC + HCC + thyroid.</a:t>
                       </a:r>
                       <a:endParaRPr lang="en-FR" sz="1000" b="0" i="0" u="none" strike="noStrike" dirty="0">
                         <a:solidFill>
@@ -7772,60 +7597,7 @@
                     <a:bodyPr/>
                     <a:lstStyle/>
                     <a:p>
-                      <a:pPr algn="ctr" fontAlgn="b">
-                        <a:buNone/>
-                      </a:pPr>
-                      <a:r>
-                        <a:rPr lang="en-FR" sz="1000" b="0" i="0" u="none" strike="noStrike" dirty="0">
-                          <a:solidFill>
-                            <a:srgbClr val="000000"/>
-                          </a:solidFill>
-                          <a:effectLst/>
-                          <a:latin typeface="Arial" panose="020B0604020202020204" pitchFamily="34" charset="0"/>
-                          <a:cs typeface="Arial" panose="020B0604020202020204" pitchFamily="34" charset="0"/>
-                        </a:rPr>
-                        <a:t>SM</a:t>
-                      </a:r>
-                    </a:p>
-                  </a:txBody>
-                  <a:tcPr marL="9525" marR="9525" marT="9525" marB="0" anchor="ctr"/>
-                </a:tc>
-                <a:tc>
-                  <a:txBody>
-                    <a:bodyPr/>
-                    <a:lstStyle/>
-                    <a:p>
-                      <a:pPr algn="ctr" fontAlgn="b">
-                        <a:buNone/>
-                      </a:pPr>
-                      <a:r>
-                        <a:rPr lang="en-FR" sz="1000" b="0" i="0" u="none" strike="noStrike" dirty="0">
-                          <a:solidFill>
-                            <a:srgbClr val="000000"/>
-                          </a:solidFill>
-                          <a:effectLst/>
-                          <a:latin typeface="Arial" panose="020B0604020202020204" pitchFamily="34" charset="0"/>
-                          <a:cs typeface="Arial" panose="020B0604020202020204" pitchFamily="34" charset="0"/>
-                        </a:rPr>
-                        <a:t>2029</a:t>
-                      </a:r>
-                    </a:p>
-                  </a:txBody>
-                  <a:tcPr marL="9525" marR="9525" marT="9525" marB="0" anchor="ctr"/>
-                </a:tc>
-                <a:extLst>
-                  <a:ext uri="{0D108BD9-81ED-4DB2-BD59-A6C34878D82A}">
-                    <a16:rowId xmlns:a16="http://schemas.microsoft.com/office/drawing/2014/main" val="1143314011"/>
-                  </a:ext>
-                </a:extLst>
-              </a:tr>
-              <a:tr h="176342">
-                <a:tc>
-                  <a:txBody>
-                    <a:bodyPr/>
-                    <a:lstStyle/>
-                    <a:p>
-                      <a:pPr algn="ctr" fontAlgn="b">
+                      <a:pPr algn="l" fontAlgn="b">
                         <a:buNone/>
                       </a:pPr>
                       <a:r>
@@ -7837,7 +7609,7 @@
                           <a:latin typeface="Arial" panose="020B0604020202020204" pitchFamily="34" charset="0"/>
                           <a:cs typeface="Arial" panose="020B0604020202020204" pitchFamily="34" charset="0"/>
                         </a:rPr>
-                        <a:t>Decapeptyl</a:t>
+                        <a:t> $            613 (+5.1%) </a:t>
                       </a:r>
                       <a:endParaRPr lang="en-FR" sz="1000" b="0" i="0" u="none" strike="noStrike" dirty="0">
                         <a:solidFill>
@@ -7860,6 +7632,506 @@
                         <a:buNone/>
                       </a:pPr>
                       <a:r>
+                        <a:rPr lang="en-FR" sz="1000" b="0" i="0" u="none" strike="noStrike" dirty="0">
+                          <a:solidFill>
+                            <a:srgbClr val="000000"/>
+                          </a:solidFill>
+                          <a:effectLst/>
+                          <a:latin typeface="Arial" panose="020B0604020202020204" pitchFamily="34" charset="0"/>
+                          <a:cs typeface="Arial" panose="020B0604020202020204" pitchFamily="34" charset="0"/>
+                        </a:rPr>
+                        <a:t>SM</a:t>
+                      </a:r>
+                    </a:p>
+                  </a:txBody>
+                  <a:tcPr marL="9525" marR="9525" marT="9525" marB="0" anchor="ctr"/>
+                </a:tc>
+                <a:tc>
+                  <a:txBody>
+                    <a:bodyPr/>
+                    <a:lstStyle/>
+                    <a:p>
+                      <a:pPr algn="ctr" fontAlgn="b">
+                        <a:buNone/>
+                      </a:pPr>
+                      <a:r>
+                        <a:rPr lang="en-FR" sz="1000" b="0" i="0" u="none" strike="noStrike" dirty="0">
+                          <a:solidFill>
+                            <a:srgbClr val="000000"/>
+                          </a:solidFill>
+                          <a:effectLst/>
+                          <a:latin typeface="Arial" panose="020B0604020202020204" pitchFamily="34" charset="0"/>
+                          <a:cs typeface="Arial" panose="020B0604020202020204" pitchFamily="34" charset="0"/>
+                        </a:rPr>
+                        <a:t>2029</a:t>
+                      </a:r>
+                    </a:p>
+                  </a:txBody>
+                  <a:tcPr marL="9525" marR="9525" marT="9525" marB="0" anchor="ctr"/>
+                </a:tc>
+                <a:extLst>
+                  <a:ext uri="{0D108BD9-81ED-4DB2-BD59-A6C34878D82A}">
+                    <a16:rowId xmlns:a16="http://schemas.microsoft.com/office/drawing/2014/main" val="1143314011"/>
+                  </a:ext>
+                </a:extLst>
+              </a:tr>
+              <a:tr h="176342">
+                <a:tc>
+                  <a:txBody>
+                    <a:bodyPr/>
+                    <a:lstStyle/>
+                    <a:p>
+                      <a:pPr algn="ctr" fontAlgn="b">
+                        <a:buNone/>
+                      </a:pPr>
+                      <a:r>
+                        <a:rPr lang="en-FR" sz="1000" b="0" u="none" strike="noStrike" dirty="0">
+                          <a:solidFill>
+                            <a:srgbClr val="000000"/>
+                          </a:solidFill>
+                          <a:effectLst/>
+                          <a:latin typeface="Arial" panose="020B0604020202020204" pitchFamily="34" charset="0"/>
+                          <a:cs typeface="Arial" panose="020B0604020202020204" pitchFamily="34" charset="0"/>
+                        </a:rPr>
+                        <a:t>Decapeptyl</a:t>
+                      </a:r>
+                      <a:endParaRPr lang="en-FR" sz="1000" b="0" i="0" u="none" strike="noStrike" dirty="0">
+                        <a:solidFill>
+                          <a:srgbClr val="000000"/>
+                        </a:solidFill>
+                        <a:effectLst/>
+                        <a:latin typeface="Arial" panose="020B0604020202020204" pitchFamily="34" charset="0"/>
+                        <a:cs typeface="Arial" panose="020B0604020202020204" pitchFamily="34" charset="0"/>
+                      </a:endParaRPr>
+                    </a:p>
+                  </a:txBody>
+                  <a:tcPr marL="9525" marR="9525" marT="9525" marB="0" anchor="ctr"/>
+                </a:tc>
+                <a:tc>
+                  <a:txBody>
+                    <a:bodyPr/>
+                    <a:lstStyle/>
+                    <a:p>
+                      <a:pPr algn="ctr" fontAlgn="b">
+                        <a:buNone/>
+                      </a:pPr>
+                      <a:r>
+                        <a:rPr lang="en-FR" sz="1000" b="0" u="none" strike="noStrike" dirty="0">
+                          <a:solidFill>
+                            <a:srgbClr val="000000"/>
+                          </a:solidFill>
+                          <a:effectLst/>
+                          <a:latin typeface="Arial" panose="020B0604020202020204" pitchFamily="34" charset="0"/>
+                          <a:cs typeface="Arial" panose="020B0604020202020204" pitchFamily="34" charset="0"/>
+                        </a:rPr>
+                        <a:t>Oncology</a:t>
+                      </a:r>
+                      <a:endParaRPr lang="en-FR" sz="1000" b="0" i="0" u="none" strike="noStrike" dirty="0">
+                        <a:solidFill>
+                          <a:srgbClr val="000000"/>
+                        </a:solidFill>
+                        <a:effectLst/>
+                        <a:latin typeface="Arial" panose="020B0604020202020204" pitchFamily="34" charset="0"/>
+                        <a:cs typeface="Arial" panose="020B0604020202020204" pitchFamily="34" charset="0"/>
+                      </a:endParaRPr>
+                    </a:p>
+                  </a:txBody>
+                  <a:tcPr marL="9525" marR="9525" marT="9525" marB="0" anchor="ctr"/>
+                </a:tc>
+                <a:tc>
+                  <a:txBody>
+                    <a:bodyPr/>
+                    <a:lstStyle/>
+                    <a:p>
+                      <a:pPr algn="ctr" fontAlgn="b">
+                        <a:buNone/>
+                      </a:pPr>
+                      <a:r>
+                        <a:rPr lang="en-GB" sz="1000" b="0" i="0" u="none" strike="noStrike" dirty="0">
+                          <a:solidFill>
+                            <a:srgbClr val="000000"/>
+                          </a:solidFill>
+                          <a:effectLst/>
+                          <a:latin typeface="Arial" panose="020B0604020202020204" pitchFamily="34" charset="0"/>
+                          <a:cs typeface="Arial" panose="020B0604020202020204" pitchFamily="34" charset="0"/>
+                        </a:rPr>
+                        <a:t>GnRH agonist</a:t>
+                      </a:r>
+                      <a:endParaRPr lang="en-FR" sz="1000" b="0" i="0" u="none" strike="noStrike" dirty="0">
+                        <a:solidFill>
+                          <a:srgbClr val="000000"/>
+                        </a:solidFill>
+                        <a:effectLst/>
+                        <a:latin typeface="Arial" panose="020B0604020202020204" pitchFamily="34" charset="0"/>
+                        <a:cs typeface="Arial" panose="020B0604020202020204" pitchFamily="34" charset="0"/>
+                      </a:endParaRPr>
+                    </a:p>
+                  </a:txBody>
+                  <a:tcPr marL="9525" marR="9525" marT="9525" marB="0" anchor="ctr"/>
+                </a:tc>
+                <a:tc>
+                  <a:txBody>
+                    <a:bodyPr/>
+                    <a:lstStyle/>
+                    <a:p>
+                      <a:pPr algn="l" fontAlgn="b">
+                        <a:buNone/>
+                      </a:pPr>
+                      <a:r>
+                        <a:rPr lang="en-GB" sz="1000" b="0" i="0" u="none" strike="noStrike" dirty="0">
+                          <a:solidFill>
+                            <a:srgbClr val="000000"/>
+                          </a:solidFill>
+                          <a:effectLst/>
+                          <a:latin typeface="Arial" panose="020B0604020202020204" pitchFamily="34" charset="0"/>
+                          <a:cs typeface="Arial" panose="020B0604020202020204" pitchFamily="34" charset="0"/>
+                        </a:rPr>
+                        <a:t>Prostate cancer + endometriosis</a:t>
+                      </a:r>
+                      <a:endParaRPr lang="en-FR" sz="1000" b="0" i="0" u="none" strike="noStrike" dirty="0">
+                        <a:solidFill>
+                          <a:srgbClr val="000000"/>
+                        </a:solidFill>
+                        <a:effectLst/>
+                        <a:latin typeface="Arial" panose="020B0604020202020204" pitchFamily="34" charset="0"/>
+                        <a:cs typeface="Arial" panose="020B0604020202020204" pitchFamily="34" charset="0"/>
+                      </a:endParaRPr>
+                    </a:p>
+                  </a:txBody>
+                  <a:tcPr marL="9525" marR="9525" marT="9525" marB="0" anchor="ctr"/>
+                </a:tc>
+                <a:tc>
+                  <a:txBody>
+                    <a:bodyPr/>
+                    <a:lstStyle/>
+                    <a:p>
+                      <a:pPr algn="l" fontAlgn="b">
+                        <a:buNone/>
+                      </a:pPr>
+                      <a:r>
+                        <a:rPr lang="en-FR" sz="1000" b="0" u="none" strike="noStrike" dirty="0">
+                          <a:solidFill>
+                            <a:srgbClr val="000000"/>
+                          </a:solidFill>
+                          <a:effectLst/>
+                          <a:latin typeface="Arial" panose="020B0604020202020204" pitchFamily="34" charset="0"/>
+                          <a:cs typeface="Arial" panose="020B0604020202020204" pitchFamily="34" charset="0"/>
+                        </a:rPr>
+                        <a:t> $            543 (+2.7%) </a:t>
+                      </a:r>
+                      <a:endParaRPr lang="en-FR" sz="1000" b="0" i="0" u="none" strike="noStrike" dirty="0">
+                        <a:solidFill>
+                          <a:srgbClr val="000000"/>
+                        </a:solidFill>
+                        <a:effectLst/>
+                        <a:latin typeface="Arial" panose="020B0604020202020204" pitchFamily="34" charset="0"/>
+                        <a:cs typeface="Arial" panose="020B0604020202020204" pitchFamily="34" charset="0"/>
+                      </a:endParaRPr>
+                    </a:p>
+                  </a:txBody>
+                  <a:tcPr marL="9525" marR="9525" marT="9525" marB="0" anchor="ctr"/>
+                </a:tc>
+                <a:tc>
+                  <a:txBody>
+                    <a:bodyPr/>
+                    <a:lstStyle/>
+                    <a:p>
+                      <a:pPr algn="ctr" fontAlgn="b">
+                        <a:buNone/>
+                      </a:pPr>
+                      <a:r>
+                        <a:rPr lang="en-FR" sz="1000" b="0" i="0" u="none" strike="noStrike" dirty="0">
+                          <a:solidFill>
+                            <a:srgbClr val="000000"/>
+                          </a:solidFill>
+                          <a:effectLst/>
+                          <a:latin typeface="Arial" panose="020B0604020202020204" pitchFamily="34" charset="0"/>
+                          <a:cs typeface="Arial" panose="020B0604020202020204" pitchFamily="34" charset="0"/>
+                        </a:rPr>
+                        <a:t>Peptide</a:t>
+                      </a:r>
+                    </a:p>
+                  </a:txBody>
+                  <a:tcPr marL="9525" marR="9525" marT="9525" marB="0" anchor="ctr"/>
+                </a:tc>
+                <a:tc>
+                  <a:txBody>
+                    <a:bodyPr/>
+                    <a:lstStyle/>
+                    <a:p>
+                      <a:pPr algn="ctr" fontAlgn="b">
+                        <a:buNone/>
+                      </a:pPr>
+                      <a:r>
+                        <a:rPr lang="en-FR" sz="1000" b="0" i="0" u="none" strike="noStrike" dirty="0">
+                          <a:solidFill>
+                            <a:srgbClr val="000000"/>
+                          </a:solidFill>
+                          <a:effectLst/>
+                          <a:latin typeface="Arial" panose="020B0604020202020204" pitchFamily="34" charset="0"/>
+                          <a:cs typeface="Arial" panose="020B0604020202020204" pitchFamily="34" charset="0"/>
+                        </a:rPr>
+                        <a:t>Expired</a:t>
+                      </a:r>
+                    </a:p>
+                  </a:txBody>
+                  <a:tcPr marL="9525" marR="9525" marT="9525" marB="0" anchor="ctr"/>
+                </a:tc>
+                <a:extLst>
+                  <a:ext uri="{0D108BD9-81ED-4DB2-BD59-A6C34878D82A}">
+                    <a16:rowId xmlns:a16="http://schemas.microsoft.com/office/drawing/2014/main" val="1831744614"/>
+                  </a:ext>
+                </a:extLst>
+              </a:tr>
+              <a:tr h="176342">
+                <a:tc>
+                  <a:txBody>
+                    <a:bodyPr/>
+                    <a:lstStyle/>
+                    <a:p>
+                      <a:pPr algn="ctr" fontAlgn="b">
+                        <a:buNone/>
+                      </a:pPr>
+                      <a:r>
+                        <a:rPr lang="en-FR" sz="1000" b="0" u="none" strike="noStrike" dirty="0">
+                          <a:solidFill>
+                            <a:srgbClr val="000000"/>
+                          </a:solidFill>
+                          <a:effectLst/>
+                          <a:latin typeface="Arial" panose="020B0604020202020204" pitchFamily="34" charset="0"/>
+                          <a:cs typeface="Arial" panose="020B0604020202020204" pitchFamily="34" charset="0"/>
+                        </a:rPr>
+                        <a:t>Onivyde</a:t>
+                      </a:r>
+                      <a:endParaRPr lang="en-FR" sz="1000" b="0" i="0" u="none" strike="noStrike" dirty="0">
+                        <a:solidFill>
+                          <a:srgbClr val="000000"/>
+                        </a:solidFill>
+                        <a:effectLst/>
+                        <a:latin typeface="Arial" panose="020B0604020202020204" pitchFamily="34" charset="0"/>
+                        <a:cs typeface="Arial" panose="020B0604020202020204" pitchFamily="34" charset="0"/>
+                      </a:endParaRPr>
+                    </a:p>
+                  </a:txBody>
+                  <a:tcPr marL="9525" marR="9525" marT="9525" marB="0" anchor="ctr"/>
+                </a:tc>
+                <a:tc>
+                  <a:txBody>
+                    <a:bodyPr/>
+                    <a:lstStyle/>
+                    <a:p>
+                      <a:pPr algn="ctr" fontAlgn="b">
+                        <a:buNone/>
+                      </a:pPr>
+                      <a:r>
+                        <a:rPr lang="en-FR" sz="1000" b="0" u="none" strike="noStrike" dirty="0">
+                          <a:solidFill>
+                            <a:srgbClr val="000000"/>
+                          </a:solidFill>
+                          <a:effectLst/>
+                          <a:latin typeface="Arial" panose="020B0604020202020204" pitchFamily="34" charset="0"/>
+                          <a:cs typeface="Arial" panose="020B0604020202020204" pitchFamily="34" charset="0"/>
+                        </a:rPr>
+                        <a:t>Oncology</a:t>
+                      </a:r>
+                      <a:endParaRPr lang="en-FR" sz="1000" b="0" i="0" u="none" strike="noStrike" dirty="0">
+                        <a:solidFill>
+                          <a:srgbClr val="000000"/>
+                        </a:solidFill>
+                        <a:effectLst/>
+                        <a:latin typeface="Arial" panose="020B0604020202020204" pitchFamily="34" charset="0"/>
+                        <a:cs typeface="Arial" panose="020B0604020202020204" pitchFamily="34" charset="0"/>
+                      </a:endParaRPr>
+                    </a:p>
+                  </a:txBody>
+                  <a:tcPr marL="9525" marR="9525" marT="9525" marB="0" anchor="ctr"/>
+                </a:tc>
+                <a:tc>
+                  <a:txBody>
+                    <a:bodyPr/>
+                    <a:lstStyle/>
+                    <a:p>
+                      <a:pPr algn="ctr" fontAlgn="b">
+                        <a:buNone/>
+                      </a:pPr>
+                      <a:r>
+                        <a:rPr lang="en-GB" sz="1000" b="0" i="0" u="none" strike="noStrike" dirty="0">
+                          <a:solidFill>
+                            <a:srgbClr val="000000"/>
+                          </a:solidFill>
+                          <a:effectLst/>
+                          <a:latin typeface="Arial" panose="020B0604020202020204" pitchFamily="34" charset="0"/>
+                          <a:cs typeface="Arial" panose="020B0604020202020204" pitchFamily="34" charset="0"/>
+                        </a:rPr>
+                        <a:t>topoisomerase I inhibitor</a:t>
+                      </a:r>
+                      <a:endParaRPr lang="en-FR" sz="1000" b="0" i="0" u="none" strike="noStrike" dirty="0">
+                        <a:solidFill>
+                          <a:srgbClr val="000000"/>
+                        </a:solidFill>
+                        <a:effectLst/>
+                        <a:latin typeface="Arial" panose="020B0604020202020204" pitchFamily="34" charset="0"/>
+                        <a:cs typeface="Arial" panose="020B0604020202020204" pitchFamily="34" charset="0"/>
+                      </a:endParaRPr>
+                    </a:p>
+                  </a:txBody>
+                  <a:tcPr marL="9525" marR="9525" marT="9525" marB="0" anchor="ctr"/>
+                </a:tc>
+                <a:tc>
+                  <a:txBody>
+                    <a:bodyPr/>
+                    <a:lstStyle/>
+                    <a:p>
+                      <a:pPr algn="l" fontAlgn="b">
+                        <a:buNone/>
+                      </a:pPr>
+                      <a:r>
+                        <a:rPr lang="en-GB" sz="1000" b="0" i="0" u="none" strike="noStrike" dirty="0">
+                          <a:solidFill>
+                            <a:srgbClr val="000000"/>
+                          </a:solidFill>
+                          <a:effectLst/>
+                          <a:latin typeface="Arial" panose="020B0604020202020204" pitchFamily="34" charset="0"/>
+                          <a:cs typeface="Arial" panose="020B0604020202020204" pitchFamily="34" charset="0"/>
+                        </a:rPr>
+                        <a:t>Pancreatic (PDAC)</a:t>
+                      </a:r>
+                      <a:endParaRPr lang="en-FR" sz="1000" b="0" i="0" u="none" strike="noStrike" dirty="0">
+                        <a:solidFill>
+                          <a:srgbClr val="000000"/>
+                        </a:solidFill>
+                        <a:effectLst/>
+                        <a:latin typeface="Arial" panose="020B0604020202020204" pitchFamily="34" charset="0"/>
+                        <a:cs typeface="Arial" panose="020B0604020202020204" pitchFamily="34" charset="0"/>
+                      </a:endParaRPr>
+                    </a:p>
+                  </a:txBody>
+                  <a:tcPr marL="9525" marR="9525" marT="9525" marB="0" anchor="ctr"/>
+                </a:tc>
+                <a:tc>
+                  <a:txBody>
+                    <a:bodyPr/>
+                    <a:lstStyle/>
+                    <a:p>
+                      <a:pPr algn="l" fontAlgn="b">
+                        <a:buNone/>
+                      </a:pPr>
+                      <a:r>
+                        <a:rPr lang="en-FR" sz="1000" b="0" u="none" strike="noStrike" dirty="0">
+                          <a:solidFill>
+                            <a:srgbClr val="000000"/>
+                          </a:solidFill>
+                          <a:effectLst/>
+                          <a:latin typeface="Arial" panose="020B0604020202020204" pitchFamily="34" charset="0"/>
+                          <a:cs typeface="Arial" panose="020B0604020202020204" pitchFamily="34" charset="0"/>
+                        </a:rPr>
+                        <a:t> $            207 (+6.2%) </a:t>
+                      </a:r>
+                      <a:endParaRPr lang="en-FR" sz="1000" b="0" i="0" u="none" strike="noStrike" dirty="0">
+                        <a:solidFill>
+                          <a:srgbClr val="000000"/>
+                        </a:solidFill>
+                        <a:effectLst/>
+                        <a:latin typeface="Arial" panose="020B0604020202020204" pitchFamily="34" charset="0"/>
+                        <a:cs typeface="Arial" panose="020B0604020202020204" pitchFamily="34" charset="0"/>
+                      </a:endParaRPr>
+                    </a:p>
+                  </a:txBody>
+                  <a:tcPr marL="9525" marR="9525" marT="9525" marB="0" anchor="ctr"/>
+                </a:tc>
+                <a:tc>
+                  <a:txBody>
+                    <a:bodyPr/>
+                    <a:lstStyle/>
+                    <a:p>
+                      <a:pPr algn="ctr" fontAlgn="b">
+                        <a:buNone/>
+                      </a:pPr>
+                      <a:r>
+                        <a:rPr lang="en-FR" sz="1000" b="0" i="0" u="none" strike="noStrike" dirty="0">
+                          <a:solidFill>
+                            <a:srgbClr val="000000"/>
+                          </a:solidFill>
+                          <a:effectLst/>
+                          <a:latin typeface="Arial" panose="020B0604020202020204" pitchFamily="34" charset="0"/>
+                          <a:cs typeface="Arial" panose="020B0604020202020204" pitchFamily="34" charset="0"/>
+                        </a:rPr>
+                        <a:t>SM</a:t>
+                      </a:r>
+                    </a:p>
+                  </a:txBody>
+                  <a:tcPr marL="9525" marR="9525" marT="9525" marB="0" anchor="ctr"/>
+                </a:tc>
+                <a:tc>
+                  <a:txBody>
+                    <a:bodyPr/>
+                    <a:lstStyle/>
+                    <a:p>
+                      <a:pPr algn="ctr" fontAlgn="b">
+                        <a:buNone/>
+                      </a:pPr>
+                      <a:r>
+                        <a:rPr lang="en-FR" sz="1000" b="0" i="0" u="none" strike="noStrike" dirty="0">
+                          <a:solidFill>
+                            <a:srgbClr val="000000"/>
+                          </a:solidFill>
+                          <a:effectLst/>
+                          <a:latin typeface="Arial" panose="020B0604020202020204" pitchFamily="34" charset="0"/>
+                          <a:cs typeface="Arial" panose="020B0604020202020204" pitchFamily="34" charset="0"/>
+                        </a:rPr>
+                        <a:t>2036</a:t>
+                      </a:r>
+                    </a:p>
+                  </a:txBody>
+                  <a:tcPr marL="9525" marR="9525" marT="9525" marB="0" anchor="ctr"/>
+                </a:tc>
+                <a:extLst>
+                  <a:ext uri="{0D108BD9-81ED-4DB2-BD59-A6C34878D82A}">
+                    <a16:rowId xmlns:a16="http://schemas.microsoft.com/office/drawing/2014/main" val="2702811013"/>
+                  </a:ext>
+                </a:extLst>
+              </a:tr>
+              <a:tr h="205733">
+                <a:tc>
+                  <a:txBody>
+                    <a:bodyPr/>
+                    <a:lstStyle/>
+                    <a:p>
+                      <a:pPr algn="ctr" fontAlgn="b">
+                        <a:buNone/>
+                      </a:pPr>
+                      <a:r>
+                        <a:rPr lang="en-FR" sz="1000" b="0" u="none" strike="noStrike" dirty="0">
+                          <a:solidFill>
+                            <a:srgbClr val="000000"/>
+                          </a:solidFill>
+                          <a:effectLst/>
+                          <a:latin typeface="Arial" panose="020B0604020202020204" pitchFamily="34" charset="0"/>
+                          <a:cs typeface="Arial" panose="020B0604020202020204" pitchFamily="34" charset="0"/>
+                        </a:rPr>
+                        <a:t>Iqirvo</a:t>
+                      </a:r>
+                      <a:endParaRPr lang="en-FR" sz="1000" b="0" i="0" u="none" strike="noStrike" dirty="0">
+                        <a:solidFill>
+                          <a:srgbClr val="000000"/>
+                        </a:solidFill>
+                        <a:effectLst/>
+                        <a:latin typeface="Arial" panose="020B0604020202020204" pitchFamily="34" charset="0"/>
+                        <a:cs typeface="Arial" panose="020B0604020202020204" pitchFamily="34" charset="0"/>
+                      </a:endParaRPr>
+                    </a:p>
+                  </a:txBody>
+                  <a:tcPr marL="9525" marR="9525" marT="9525" marB="0" anchor="ctr"/>
+                </a:tc>
+                <a:tc>
+                  <a:txBody>
+                    <a:bodyPr/>
+                    <a:lstStyle/>
+                    <a:p>
+                      <a:pPr algn="ctr" fontAlgn="b">
+                        <a:buNone/>
+                      </a:pPr>
+                      <a:r>
                         <a:rPr lang="en-FR" sz="1000" b="0" u="none" strike="noStrike">
                           <a:solidFill>
                             <a:srgbClr val="000000"/>
@@ -7868,7 +8140,7 @@
                           <a:latin typeface="Arial" panose="020B0604020202020204" pitchFamily="34" charset="0"/>
                           <a:cs typeface="Arial" panose="020B0604020202020204" pitchFamily="34" charset="0"/>
                         </a:rPr>
-                        <a:t>Oncology</a:t>
+                        <a:t>Rare Diseases</a:t>
                       </a:r>
                       <a:endParaRPr lang="en-FR" sz="1000" b="0" i="0" u="none" strike="noStrike">
                         <a:solidFill>
@@ -7891,7 +8163,7 @@
                         <a:buNone/>
                       </a:pPr>
                       <a:r>
-                        <a:rPr lang="en-FR" sz="1000" b="0" u="none" strike="noStrike" dirty="0">
+                        <a:rPr lang="en-GB" sz="1000" b="0" i="0" u="none" strike="noStrike" dirty="0">
                           <a:solidFill>
                             <a:srgbClr val="000000"/>
                           </a:solidFill>
@@ -7899,7 +8171,29 @@
                           <a:latin typeface="Arial" panose="020B0604020202020204" pitchFamily="34" charset="0"/>
                           <a:cs typeface="Arial" panose="020B0604020202020204" pitchFamily="34" charset="0"/>
                         </a:rPr>
-                        <a:t> $            543 </a:t>
+                        <a:t>PPAR</a:t>
+                      </a:r>
+                      <a:r>
+                        <a:rPr lang="el-GR" sz="1000" b="0" i="0" u="none" strike="noStrike" dirty="0">
+                          <a:solidFill>
+                            <a:srgbClr val="000000"/>
+                          </a:solidFill>
+                          <a:effectLst/>
+                          <a:latin typeface="Arial" panose="020B0604020202020204" pitchFamily="34" charset="0"/>
+                          <a:cs typeface="Arial" panose="020B0604020202020204" pitchFamily="34" charset="0"/>
+                        </a:rPr>
+                        <a:t>α/δ </a:t>
+                      </a:r>
+                      <a:r>
+                        <a:rPr lang="en-GB" sz="1000" b="0" i="0" u="none" strike="noStrike" dirty="0">
+                          <a:solidFill>
+                            <a:srgbClr val="000000"/>
+                          </a:solidFill>
+                          <a:effectLst/>
+                          <a:latin typeface="Arial" panose="020B0604020202020204" pitchFamily="34" charset="0"/>
+                          <a:cs typeface="Arial" panose="020B0604020202020204" pitchFamily="34" charset="0"/>
+                        </a:rPr>
+                        <a:t>agonist</a:t>
                       </a:r>
                       <a:endParaRPr lang="en-FR" sz="1000" b="0" i="0" u="none" strike="noStrike" dirty="0">
                         <a:solidFill>
@@ -7918,11 +8212,11 @@
                     <a:bodyPr/>
                     <a:lstStyle/>
                     <a:p>
-                      <a:pPr algn="ctr" fontAlgn="b">
-                        <a:buNone/>
-                      </a:pPr>
-                      <a:r>
-                        <a:rPr lang="en-FR" sz="1000" b="0" u="none" strike="noStrike" dirty="0">
+                      <a:pPr algn="l" fontAlgn="b">
+                        <a:buNone/>
+                      </a:pPr>
+                      <a:r>
+                        <a:rPr lang="en-GB" sz="1000" b="0" i="0" u="none" strike="noStrike" dirty="0">
                           <a:solidFill>
                             <a:srgbClr val="000000"/>
                           </a:solidFill>
@@ -7930,7 +8224,7 @@
                           <a:latin typeface="Arial" panose="020B0604020202020204" pitchFamily="34" charset="0"/>
                           <a:cs typeface="Arial" panose="020B0604020202020204" pitchFamily="34" charset="0"/>
                         </a:rPr>
-                        <a:t>2.7%</a:t>
+                        <a:t>PBC (primary biliary cholangitis).</a:t>
                       </a:r>
                       <a:endParaRPr lang="en-FR" sz="1000" b="0" i="0" u="none" strike="noStrike" dirty="0">
                         <a:solidFill>
@@ -7949,60 +8243,7 @@
                     <a:bodyPr/>
                     <a:lstStyle/>
                     <a:p>
-                      <a:pPr algn="ctr" fontAlgn="b">
-                        <a:buNone/>
-                      </a:pPr>
-                      <a:r>
-                        <a:rPr lang="en-FR" sz="1000" b="0" i="0" u="none" strike="noStrike" dirty="0">
-                          <a:solidFill>
-                            <a:srgbClr val="000000"/>
-                          </a:solidFill>
-                          <a:effectLst/>
-                          <a:latin typeface="Arial" panose="020B0604020202020204" pitchFamily="34" charset="0"/>
-                          <a:cs typeface="Arial" panose="020B0604020202020204" pitchFamily="34" charset="0"/>
-                        </a:rPr>
-                        <a:t>Peptid</a:t>
-                      </a:r>
-                    </a:p>
-                  </a:txBody>
-                  <a:tcPr marL="9525" marR="9525" marT="9525" marB="0" anchor="ctr"/>
-                </a:tc>
-                <a:tc>
-                  <a:txBody>
-                    <a:bodyPr/>
-                    <a:lstStyle/>
-                    <a:p>
-                      <a:pPr algn="ctr" fontAlgn="b">
-                        <a:buNone/>
-                      </a:pPr>
-                      <a:r>
-                        <a:rPr lang="en-FR" sz="1000" b="0" i="0" u="none" strike="noStrike" dirty="0">
-                          <a:solidFill>
-                            <a:srgbClr val="000000"/>
-                          </a:solidFill>
-                          <a:effectLst/>
-                          <a:latin typeface="Arial" panose="020B0604020202020204" pitchFamily="34" charset="0"/>
-                          <a:cs typeface="Arial" panose="020B0604020202020204" pitchFamily="34" charset="0"/>
-                        </a:rPr>
-                        <a:t>Expired</a:t>
-                      </a:r>
-                    </a:p>
-                  </a:txBody>
-                  <a:tcPr marL="9525" marR="9525" marT="9525" marB="0" anchor="ctr"/>
-                </a:tc>
-                <a:extLst>
-                  <a:ext uri="{0D108BD9-81ED-4DB2-BD59-A6C34878D82A}">
-                    <a16:rowId xmlns:a16="http://schemas.microsoft.com/office/drawing/2014/main" val="1831744614"/>
-                  </a:ext>
-                </a:extLst>
-              </a:tr>
-              <a:tr h="176342">
-                <a:tc>
-                  <a:txBody>
-                    <a:bodyPr/>
-                    <a:lstStyle/>
-                    <a:p>
-                      <a:pPr algn="ctr" fontAlgn="b">
+                      <a:pPr algn="l" fontAlgn="b">
                         <a:buNone/>
                       </a:pPr>
                       <a:r>
@@ -8014,7 +8255,7 @@
                           <a:latin typeface="Arial" panose="020B0604020202020204" pitchFamily="34" charset="0"/>
                           <a:cs typeface="Arial" panose="020B0604020202020204" pitchFamily="34" charset="0"/>
                         </a:rPr>
-                        <a:t>Onivyde</a:t>
+                        <a:t> $            184 (launched) </a:t>
                       </a:r>
                       <a:endParaRPr lang="en-FR" sz="1000" b="0" i="0" u="none" strike="noStrike" dirty="0">
                         <a:solidFill>
@@ -8037,6 +8278,90 @@
                         <a:buNone/>
                       </a:pPr>
                       <a:r>
+                        <a:rPr lang="en-FR" sz="1000" b="0" i="0" u="none" strike="noStrike" dirty="0">
+                          <a:solidFill>
+                            <a:srgbClr val="000000"/>
+                          </a:solidFill>
+                          <a:effectLst/>
+                          <a:latin typeface="Arial" panose="020B0604020202020204" pitchFamily="34" charset="0"/>
+                          <a:cs typeface="Arial" panose="020B0604020202020204" pitchFamily="34" charset="0"/>
+                        </a:rPr>
+                        <a:t>SM</a:t>
+                      </a:r>
+                    </a:p>
+                  </a:txBody>
+                  <a:tcPr marL="9525" marR="9525" marT="9525" marB="0" anchor="ctr"/>
+                </a:tc>
+                <a:tc>
+                  <a:txBody>
+                    <a:bodyPr/>
+                    <a:lstStyle/>
+                    <a:p>
+                      <a:pPr algn="ctr" fontAlgn="b">
+                        <a:buNone/>
+                      </a:pPr>
+                      <a:r>
+                        <a:rPr lang="en-FR" sz="1000" b="0" i="0" u="none" strike="noStrike" dirty="0">
+                          <a:solidFill>
+                            <a:srgbClr val="000000"/>
+                          </a:solidFill>
+                          <a:effectLst/>
+                          <a:latin typeface="Arial" panose="020B0604020202020204" pitchFamily="34" charset="0"/>
+                          <a:cs typeface="Arial" panose="020B0604020202020204" pitchFamily="34" charset="0"/>
+                        </a:rPr>
+                        <a:t>2037</a:t>
+                      </a:r>
+                    </a:p>
+                  </a:txBody>
+                  <a:tcPr marL="9525" marR="9525" marT="9525" marB="0" anchor="ctr"/>
+                </a:tc>
+                <a:extLst>
+                  <a:ext uri="{0D108BD9-81ED-4DB2-BD59-A6C34878D82A}">
+                    <a16:rowId xmlns:a16="http://schemas.microsoft.com/office/drawing/2014/main" val="706977273"/>
+                  </a:ext>
+                </a:extLst>
+              </a:tr>
+              <a:tr h="205733">
+                <a:tc>
+                  <a:txBody>
+                    <a:bodyPr/>
+                    <a:lstStyle/>
+                    <a:p>
+                      <a:pPr algn="ctr" fontAlgn="b">
+                        <a:buNone/>
+                      </a:pPr>
+                      <a:r>
+                        <a:rPr lang="en-FR" sz="1000" b="0" u="none" strike="noStrike" dirty="0">
+                          <a:solidFill>
+                            <a:srgbClr val="000000"/>
+                          </a:solidFill>
+                          <a:effectLst/>
+                          <a:latin typeface="Arial" panose="020B0604020202020204" pitchFamily="34" charset="0"/>
+                          <a:cs typeface="Arial" panose="020B0604020202020204" pitchFamily="34" charset="0"/>
+                        </a:rPr>
+                        <a:t>Bylvay</a:t>
+                      </a:r>
+                      <a:endParaRPr lang="en-FR" sz="1000" b="0" i="0" u="none" strike="noStrike" dirty="0">
+                        <a:solidFill>
+                          <a:srgbClr val="000000"/>
+                        </a:solidFill>
+                        <a:effectLst/>
+                        <a:latin typeface="Arial" panose="020B0604020202020204" pitchFamily="34" charset="0"/>
+                        <a:cs typeface="Arial" panose="020B0604020202020204" pitchFamily="34" charset="0"/>
+                      </a:endParaRPr>
+                    </a:p>
+                  </a:txBody>
+                  <a:tcPr marL="9525" marR="9525" marT="9525" marB="0" anchor="ctr"/>
+                </a:tc>
+                <a:tc>
+                  <a:txBody>
+                    <a:bodyPr/>
+                    <a:lstStyle/>
+                    <a:p>
+                      <a:pPr algn="ctr" fontAlgn="b">
+                        <a:buNone/>
+                      </a:pPr>
+                      <a:r>
                         <a:rPr lang="en-FR" sz="1000" b="0" u="none" strike="noStrike">
                           <a:solidFill>
                             <a:srgbClr val="000000"/>
@@ -8045,7 +8370,7 @@
                           <a:latin typeface="Arial" panose="020B0604020202020204" pitchFamily="34" charset="0"/>
                           <a:cs typeface="Arial" panose="020B0604020202020204" pitchFamily="34" charset="0"/>
                         </a:rPr>
-                        <a:t>Oncology</a:t>
+                        <a:t>Rare Diseases</a:t>
                       </a:r>
                       <a:endParaRPr lang="en-FR" sz="1000" b="0" i="0" u="none" strike="noStrike">
                         <a:solidFill>
@@ -8068,7 +8393,7 @@
                         <a:buNone/>
                       </a:pPr>
                       <a:r>
-                        <a:rPr lang="en-FR" sz="1000" b="0" u="none" strike="noStrike" dirty="0">
+                        <a:rPr lang="en-GB" sz="1000" b="0" i="0" u="none" strike="noStrike" dirty="0">
                           <a:solidFill>
                             <a:srgbClr val="000000"/>
                           </a:solidFill>
@@ -8076,7 +8401,7 @@
                           <a:latin typeface="Arial" panose="020B0604020202020204" pitchFamily="34" charset="0"/>
                           <a:cs typeface="Arial" panose="020B0604020202020204" pitchFamily="34" charset="0"/>
                         </a:rPr>
-                        <a:t> $            207 </a:t>
+                        <a:t>IBAT inhibitor</a:t>
                       </a:r>
                       <a:endParaRPr lang="en-FR" sz="1000" b="0" i="0" u="none" strike="noStrike" dirty="0">
                         <a:solidFill>
@@ -8095,11 +8420,11 @@
                     <a:bodyPr/>
                     <a:lstStyle/>
                     <a:p>
-                      <a:pPr algn="ctr" fontAlgn="b">
-                        <a:buNone/>
-                      </a:pPr>
-                      <a:r>
-                        <a:rPr lang="en-FR" sz="1000" b="0" u="none" strike="noStrike" dirty="0">
+                      <a:pPr algn="l" fontAlgn="b">
+                        <a:buNone/>
+                      </a:pPr>
+                      <a:r>
+                        <a:rPr lang="en-GB" sz="1000" b="0" i="0" u="none" strike="noStrike" dirty="0">
                           <a:solidFill>
                             <a:srgbClr val="000000"/>
                           </a:solidFill>
@@ -8107,7 +8432,7 @@
                           <a:latin typeface="Arial" panose="020B0604020202020204" pitchFamily="34" charset="0"/>
                           <a:cs typeface="Arial" panose="020B0604020202020204" pitchFamily="34" charset="0"/>
                         </a:rPr>
-                        <a:t>6.2%</a:t>
+                        <a:t>Cholestatic liver (PFIC, biliary atresia).</a:t>
                       </a:r>
                       <a:endParaRPr lang="en-FR" sz="1000" b="0" i="0" u="none" strike="noStrike" dirty="0">
                         <a:solidFill>
@@ -8126,60 +8451,7 @@
                     <a:bodyPr/>
                     <a:lstStyle/>
                     <a:p>
-                      <a:pPr algn="ctr" fontAlgn="b">
-                        <a:buNone/>
-                      </a:pPr>
-                      <a:r>
-                        <a:rPr lang="en-FR" sz="1000" b="0" i="0" u="none" strike="noStrike" dirty="0">
-                          <a:solidFill>
-                            <a:srgbClr val="000000"/>
-                          </a:solidFill>
-                          <a:effectLst/>
-                          <a:latin typeface="Arial" panose="020B0604020202020204" pitchFamily="34" charset="0"/>
-                          <a:cs typeface="Arial" panose="020B0604020202020204" pitchFamily="34" charset="0"/>
-                        </a:rPr>
-                        <a:t>SM</a:t>
-                      </a:r>
-                    </a:p>
-                  </a:txBody>
-                  <a:tcPr marL="9525" marR="9525" marT="9525" marB="0" anchor="ctr"/>
-                </a:tc>
-                <a:tc>
-                  <a:txBody>
-                    <a:bodyPr/>
-                    <a:lstStyle/>
-                    <a:p>
-                      <a:pPr algn="ctr" fontAlgn="b">
-                        <a:buNone/>
-                      </a:pPr>
-                      <a:r>
-                        <a:rPr lang="en-FR" sz="1000" b="0" i="0" u="none" strike="noStrike" dirty="0">
-                          <a:solidFill>
-                            <a:srgbClr val="000000"/>
-                          </a:solidFill>
-                          <a:effectLst/>
-                          <a:latin typeface="Arial" panose="020B0604020202020204" pitchFamily="34" charset="0"/>
-                          <a:cs typeface="Arial" panose="020B0604020202020204" pitchFamily="34" charset="0"/>
-                        </a:rPr>
-                        <a:t>2036</a:t>
-                      </a:r>
-                    </a:p>
-                  </a:txBody>
-                  <a:tcPr marL="9525" marR="9525" marT="9525" marB="0" anchor="ctr"/>
-                </a:tc>
-                <a:extLst>
-                  <a:ext uri="{0D108BD9-81ED-4DB2-BD59-A6C34878D82A}">
-                    <a16:rowId xmlns:a16="http://schemas.microsoft.com/office/drawing/2014/main" val="2702811013"/>
-                  </a:ext>
-                </a:extLst>
-              </a:tr>
-              <a:tr h="176342">
-                <a:tc>
-                  <a:txBody>
-                    <a:bodyPr/>
-                    <a:lstStyle/>
-                    <a:p>
-                      <a:pPr algn="ctr" fontAlgn="b">
+                      <a:pPr algn="l" fontAlgn="b">
                         <a:buNone/>
                       </a:pPr>
                       <a:r>
@@ -8191,7 +8463,7 @@
                           <a:latin typeface="Arial" panose="020B0604020202020204" pitchFamily="34" charset="0"/>
                           <a:cs typeface="Arial" panose="020B0604020202020204" pitchFamily="34" charset="0"/>
                         </a:rPr>
-                        <a:t>Tazverik</a:t>
+                        <a:t> $            180 (+36.3%) </a:t>
                       </a:r>
                       <a:endParaRPr lang="en-FR" sz="1000" b="0" i="0" u="none" strike="noStrike" dirty="0">
                         <a:solidFill>
@@ -8214,6 +8486,90 @@
                         <a:buNone/>
                       </a:pPr>
                       <a:r>
+                        <a:rPr lang="en-FR" sz="1000" b="0" i="0" u="none" strike="noStrike" dirty="0">
+                          <a:solidFill>
+                            <a:srgbClr val="000000"/>
+                          </a:solidFill>
+                          <a:effectLst/>
+                          <a:latin typeface="Arial" panose="020B0604020202020204" pitchFamily="34" charset="0"/>
+                          <a:cs typeface="Arial" panose="020B0604020202020204" pitchFamily="34" charset="0"/>
+                        </a:rPr>
+                        <a:t>SM</a:t>
+                      </a:r>
+                    </a:p>
+                  </a:txBody>
+                  <a:tcPr marL="9525" marR="9525" marT="9525" marB="0" anchor="ctr"/>
+                </a:tc>
+                <a:tc>
+                  <a:txBody>
+                    <a:bodyPr/>
+                    <a:lstStyle/>
+                    <a:p>
+                      <a:pPr algn="ctr" fontAlgn="b">
+                        <a:buNone/>
+                      </a:pPr>
+                      <a:r>
+                        <a:rPr lang="en-FR" sz="1000" b="0" i="0" u="none" strike="noStrike" dirty="0">
+                          <a:solidFill>
+                            <a:srgbClr val="000000"/>
+                          </a:solidFill>
+                          <a:effectLst/>
+                          <a:latin typeface="Arial" panose="020B0604020202020204" pitchFamily="34" charset="0"/>
+                          <a:cs typeface="Arial" panose="020B0604020202020204" pitchFamily="34" charset="0"/>
+                        </a:rPr>
+                        <a:t>2039</a:t>
+                      </a:r>
+                    </a:p>
+                  </a:txBody>
+                  <a:tcPr marL="9525" marR="9525" marT="9525" marB="0" anchor="ctr"/>
+                </a:tc>
+                <a:extLst>
+                  <a:ext uri="{0D108BD9-81ED-4DB2-BD59-A6C34878D82A}">
+                    <a16:rowId xmlns:a16="http://schemas.microsoft.com/office/drawing/2014/main" val="215480271"/>
+                  </a:ext>
+                </a:extLst>
+              </a:tr>
+              <a:tr h="205733">
+                <a:tc>
+                  <a:txBody>
+                    <a:bodyPr/>
+                    <a:lstStyle/>
+                    <a:p>
+                      <a:pPr algn="ctr" fontAlgn="b">
+                        <a:buNone/>
+                      </a:pPr>
+                      <a:r>
+                        <a:rPr lang="en-FR" sz="1000" b="0" u="none" strike="noStrike" dirty="0">
+                          <a:solidFill>
+                            <a:srgbClr val="000000"/>
+                          </a:solidFill>
+                          <a:effectLst/>
+                          <a:latin typeface="Arial" panose="020B0604020202020204" pitchFamily="34" charset="0"/>
+                          <a:cs typeface="Arial" panose="020B0604020202020204" pitchFamily="34" charset="0"/>
+                        </a:rPr>
+                        <a:t>Dysport</a:t>
+                      </a:r>
+                      <a:endParaRPr lang="en-FR" sz="1000" b="0" i="0" u="none" strike="noStrike" dirty="0">
+                        <a:solidFill>
+                          <a:srgbClr val="000000"/>
+                        </a:solidFill>
+                        <a:effectLst/>
+                        <a:latin typeface="Arial" panose="020B0604020202020204" pitchFamily="34" charset="0"/>
+                        <a:cs typeface="Arial" panose="020B0604020202020204" pitchFamily="34" charset="0"/>
+                      </a:endParaRPr>
+                    </a:p>
+                  </a:txBody>
+                  <a:tcPr marL="9525" marR="9525" marT="9525" marB="0" anchor="ctr"/>
+                </a:tc>
+                <a:tc>
+                  <a:txBody>
+                    <a:bodyPr/>
+                    <a:lstStyle/>
+                    <a:p>
+                      <a:pPr algn="ctr" fontAlgn="b">
+                        <a:buNone/>
+                      </a:pPr>
+                      <a:r>
                         <a:rPr lang="en-FR" sz="1000" b="0" u="none" strike="noStrike">
                           <a:solidFill>
                             <a:srgbClr val="000000"/>
@@ -8222,7 +8578,7 @@
                           <a:latin typeface="Arial" panose="020B0604020202020204" pitchFamily="34" charset="0"/>
                           <a:cs typeface="Arial" panose="020B0604020202020204" pitchFamily="34" charset="0"/>
                         </a:rPr>
-                        <a:t>Oncology</a:t>
+                        <a:t>Neurosciences</a:t>
                       </a:r>
                       <a:endParaRPr lang="en-FR" sz="1000" b="0" i="0" u="none" strike="noStrike">
                         <a:solidFill>
@@ -8245,7 +8601,7 @@
                         <a:buNone/>
                       </a:pPr>
                       <a:r>
-                        <a:rPr lang="en-FR" sz="1000" b="0" u="none" strike="noStrike">
+                        <a:rPr lang="en-GB" sz="1000" b="0" i="0" u="none" strike="noStrike" dirty="0">
                           <a:solidFill>
                             <a:srgbClr val="000000"/>
                           </a:solidFill>
@@ -8253,38 +8609,7 @@
                           <a:latin typeface="Arial" panose="020B0604020202020204" pitchFamily="34" charset="0"/>
                           <a:cs typeface="Arial" panose="020B0604020202020204" pitchFamily="34" charset="0"/>
                         </a:rPr>
-                        <a:t> $              41 </a:t>
-                      </a:r>
-                      <a:endParaRPr lang="en-FR" sz="1000" b="0" i="0" u="none" strike="noStrike">
-                        <a:solidFill>
-                          <a:srgbClr val="000000"/>
-                        </a:solidFill>
-                        <a:effectLst/>
-                        <a:latin typeface="Arial" panose="020B0604020202020204" pitchFamily="34" charset="0"/>
-                        <a:cs typeface="Arial" panose="020B0604020202020204" pitchFamily="34" charset="0"/>
-                      </a:endParaRPr>
-                    </a:p>
-                  </a:txBody>
-                  <a:tcPr marL="9525" marR="9525" marT="9525" marB="0" anchor="ctr"/>
-                </a:tc>
-                <a:tc>
-                  <a:txBody>
-                    <a:bodyPr/>
-                    <a:lstStyle/>
-                    <a:p>
-                      <a:pPr algn="ctr" fontAlgn="b">
-                        <a:buNone/>
-                      </a:pPr>
-                      <a:r>
-                        <a:rPr lang="en-FR" sz="1000" b="0" u="none" strike="noStrike" dirty="0">
-                          <a:solidFill>
-                            <a:srgbClr val="000000"/>
-                          </a:solidFill>
-                          <a:effectLst/>
-                          <a:latin typeface="Arial" panose="020B0604020202020204" pitchFamily="34" charset="0"/>
-                          <a:cs typeface="Arial" panose="020B0604020202020204" pitchFamily="34" charset="0"/>
-                        </a:rPr>
-                        <a:t>-9.1%</a:t>
+                        <a:t>Botulinum toxin type A</a:t>
                       </a:r>
                       <a:endParaRPr lang="en-FR" sz="1000" b="0" i="0" u="none" strike="noStrike" dirty="0">
                         <a:solidFill>
@@ -8303,45 +8628,8 @@
                     <a:bodyPr/>
                     <a:lstStyle/>
                     <a:p>
-                      <a:pPr algn="ctr" fontAlgn="b">
-                        <a:buNone/>
-                      </a:pPr>
-                      <a:r>
-                        <a:rPr lang="en-FR" sz="1000" b="0" i="0" u="none" strike="noStrike" dirty="0">
-                          <a:solidFill>
-                            <a:srgbClr val="000000"/>
-                          </a:solidFill>
-                          <a:effectLst/>
-                          <a:latin typeface="Arial" panose="020B0604020202020204" pitchFamily="34" charset="0"/>
-                          <a:cs typeface="Arial" panose="020B0604020202020204" pitchFamily="34" charset="0"/>
-                        </a:rPr>
-                        <a:t>SM</a:t>
-                      </a:r>
-                    </a:p>
-                  </a:txBody>
-                  <a:tcPr marL="9525" marR="9525" marT="9525" marB="0" anchor="ctr"/>
-                </a:tc>
-                <a:tc>
-                  <a:txBody>
-                    <a:bodyPr/>
-                    <a:lstStyle/>
-                    <a:p>
-                      <a:pPr marL="0" marR="0" lvl="0" indent="0" algn="ctr" defTabSz="914400" rtl="0" eaLnBrk="1" fontAlgn="b" latinLnBrk="0" hangingPunct="1">
-                        <a:lnSpc>
-                          <a:spcPct val="100000"/>
-                        </a:lnSpc>
-                        <a:spcBef>
-                          <a:spcPts val="0"/>
-                        </a:spcBef>
-                        <a:spcAft>
-                          <a:spcPts val="0"/>
-                        </a:spcAft>
-                        <a:buClrTx/>
-                        <a:buSzTx/>
-                        <a:buFontTx/>
-                        <a:buNone/>
-                        <a:tabLst/>
-                        <a:defRPr/>
+                      <a:pPr algn="l" fontAlgn="b">
+                        <a:buNone/>
                       </a:pPr>
                       <a:r>
                         <a:rPr lang="en-GB" sz="1000" b="0" i="0" u="none" strike="noStrike" dirty="0">
@@ -8352,56 +8640,7 @@
                           <a:latin typeface="Arial" panose="020B0604020202020204" pitchFamily="34" charset="0"/>
                           <a:cs typeface="Arial" panose="020B0604020202020204" pitchFamily="34" charset="0"/>
                         </a:rPr>
-                        <a:t>2032 (withdrew</a:t>
-                      </a:r>
-                      <a:r>
-                        <a:rPr lang="en-FR" sz="1000" b="0" i="0" u="none" strike="noStrike" dirty="0">
-                          <a:solidFill>
-                            <a:srgbClr val="000000"/>
-                          </a:solidFill>
-                          <a:effectLst/>
-                          <a:latin typeface="Arial" panose="020B0604020202020204" pitchFamily="34" charset="0"/>
-                          <a:cs typeface="Arial" panose="020B0604020202020204" pitchFamily="34" charset="0"/>
-                        </a:rPr>
-                        <a:t>)</a:t>
-                      </a:r>
-                      <a:endParaRPr lang="en-GB" sz="1000" b="0" i="0" u="none" strike="noStrike" dirty="0">
-                        <a:solidFill>
-                          <a:srgbClr val="000000"/>
-                        </a:solidFill>
-                        <a:effectLst/>
-                        <a:latin typeface="Arial" panose="020B0604020202020204" pitchFamily="34" charset="0"/>
-                        <a:cs typeface="Arial" panose="020B0604020202020204" pitchFamily="34" charset="0"/>
-                      </a:endParaRPr>
-                    </a:p>
-                  </a:txBody>
-                  <a:tcPr marL="9525" marR="9525" marT="9525" marB="0" anchor="ctr"/>
-                </a:tc>
-                <a:extLst>
-                  <a:ext uri="{0D108BD9-81ED-4DB2-BD59-A6C34878D82A}">
-                    <a16:rowId xmlns:a16="http://schemas.microsoft.com/office/drawing/2014/main" val="3431630276"/>
-                  </a:ext>
-                </a:extLst>
-              </a:tr>
-              <a:tr h="205733">
-                <a:tc>
-                  <a:txBody>
-                    <a:bodyPr/>
-                    <a:lstStyle/>
-                    <a:p>
-                      <a:pPr algn="ctr" fontAlgn="b">
-                        <a:buNone/>
-                      </a:pPr>
-                      <a:r>
-                        <a:rPr lang="en-FR" sz="1000" b="0" u="none" strike="noStrike" dirty="0">
-                          <a:solidFill>
-                            <a:srgbClr val="000000"/>
-                          </a:solidFill>
-                          <a:effectLst/>
-                          <a:latin typeface="Arial" panose="020B0604020202020204" pitchFamily="34" charset="0"/>
-                          <a:cs typeface="Arial" panose="020B0604020202020204" pitchFamily="34" charset="0"/>
-                        </a:rPr>
-                        <a:t>Iqirvo</a:t>
+                        <a:t>Aesthetic + therapeutic (spasticity, dystonia, migraine).</a:t>
                       </a:r>
                       <a:endParaRPr lang="en-FR" sz="1000" b="0" i="0" u="none" strike="noStrike" dirty="0">
                         <a:solidFill>
@@ -8420,69 +8659,7 @@
                     <a:bodyPr/>
                     <a:lstStyle/>
                     <a:p>
-                      <a:pPr algn="ctr" fontAlgn="b">
-                        <a:buNone/>
-                      </a:pPr>
-                      <a:r>
-                        <a:rPr lang="en-FR" sz="1000" b="0" u="none" strike="noStrike">
-                          <a:solidFill>
-                            <a:srgbClr val="000000"/>
-                          </a:solidFill>
-                          <a:effectLst/>
-                          <a:latin typeface="Arial" panose="020B0604020202020204" pitchFamily="34" charset="0"/>
-                          <a:cs typeface="Arial" panose="020B0604020202020204" pitchFamily="34" charset="0"/>
-                        </a:rPr>
-                        <a:t>Rare Diseases</a:t>
-                      </a:r>
-                      <a:endParaRPr lang="en-FR" sz="1000" b="0" i="0" u="none" strike="noStrike">
-                        <a:solidFill>
-                          <a:srgbClr val="000000"/>
-                        </a:solidFill>
-                        <a:effectLst/>
-                        <a:latin typeface="Arial" panose="020B0604020202020204" pitchFamily="34" charset="0"/>
-                        <a:cs typeface="Arial" panose="020B0604020202020204" pitchFamily="34" charset="0"/>
-                      </a:endParaRPr>
-                    </a:p>
-                  </a:txBody>
-                  <a:tcPr marL="9525" marR="9525" marT="9525" marB="0" anchor="ctr"/>
-                </a:tc>
-                <a:tc>
-                  <a:txBody>
-                    <a:bodyPr/>
-                    <a:lstStyle/>
-                    <a:p>
-                      <a:pPr algn="ctr" fontAlgn="b">
-                        <a:buNone/>
-                      </a:pPr>
-                      <a:r>
-                        <a:rPr lang="en-FR" sz="1000" b="0" u="none" strike="noStrike">
-                          <a:solidFill>
-                            <a:srgbClr val="000000"/>
-                          </a:solidFill>
-                          <a:effectLst/>
-                          <a:latin typeface="Arial" panose="020B0604020202020204" pitchFamily="34" charset="0"/>
-                          <a:cs typeface="Arial" panose="020B0604020202020204" pitchFamily="34" charset="0"/>
-                        </a:rPr>
-                        <a:t> $            184 </a:t>
-                      </a:r>
-                      <a:endParaRPr lang="en-FR" sz="1000" b="0" i="0" u="none" strike="noStrike">
-                        <a:solidFill>
-                          <a:srgbClr val="000000"/>
-                        </a:solidFill>
-                        <a:effectLst/>
-                        <a:latin typeface="Arial" panose="020B0604020202020204" pitchFamily="34" charset="0"/>
-                        <a:cs typeface="Arial" panose="020B0604020202020204" pitchFamily="34" charset="0"/>
-                      </a:endParaRPr>
-                    </a:p>
-                  </a:txBody>
-                  <a:tcPr marL="9525" marR="9525" marT="9525" marB="0" anchor="ctr"/>
-                </a:tc>
-                <a:tc>
-                  <a:txBody>
-                    <a:bodyPr/>
-                    <a:lstStyle/>
-                    <a:p>
-                      <a:pPr algn="ctr" fontAlgn="b">
+                      <a:pPr algn="l" fontAlgn="b">
                         <a:buNone/>
                       </a:pPr>
                       <a:r>
@@ -8494,540 +8671,9 @@
                           <a:latin typeface="Arial" panose="020B0604020202020204" pitchFamily="34" charset="0"/>
                           <a:cs typeface="Arial" panose="020B0604020202020204" pitchFamily="34" charset="0"/>
                         </a:rPr>
-                        <a:t>n/a</a:t>
+                        <a:t> $            734 (+9.7%) </a:t>
                       </a:r>
                       <a:endParaRPr lang="en-FR" sz="1000" b="0" i="0" u="none" strike="noStrike" dirty="0">
-                        <a:solidFill>
-                          <a:srgbClr val="000000"/>
-                        </a:solidFill>
-                        <a:effectLst/>
-                        <a:latin typeface="Arial" panose="020B0604020202020204" pitchFamily="34" charset="0"/>
-                        <a:cs typeface="Arial" panose="020B0604020202020204" pitchFamily="34" charset="0"/>
-                      </a:endParaRPr>
-                    </a:p>
-                  </a:txBody>
-                  <a:tcPr marL="9525" marR="9525" marT="9525" marB="0" anchor="ctr"/>
-                </a:tc>
-                <a:tc>
-                  <a:txBody>
-                    <a:bodyPr/>
-                    <a:lstStyle/>
-                    <a:p>
-                      <a:pPr algn="ctr" fontAlgn="b">
-                        <a:buNone/>
-                      </a:pPr>
-                      <a:r>
-                        <a:rPr lang="en-FR" sz="1000" b="0" i="0" u="none" strike="noStrike" dirty="0">
-                          <a:solidFill>
-                            <a:srgbClr val="000000"/>
-                          </a:solidFill>
-                          <a:effectLst/>
-                          <a:latin typeface="Arial" panose="020B0604020202020204" pitchFamily="34" charset="0"/>
-                          <a:cs typeface="Arial" panose="020B0604020202020204" pitchFamily="34" charset="0"/>
-                        </a:rPr>
-                        <a:t>SM</a:t>
-                      </a:r>
-                    </a:p>
-                  </a:txBody>
-                  <a:tcPr marL="9525" marR="9525" marT="9525" marB="0" anchor="ctr"/>
-                </a:tc>
-                <a:tc>
-                  <a:txBody>
-                    <a:bodyPr/>
-                    <a:lstStyle/>
-                    <a:p>
-                      <a:pPr algn="ctr" fontAlgn="b">
-                        <a:buNone/>
-                      </a:pPr>
-                      <a:r>
-                        <a:rPr lang="en-FR" sz="1000" b="0" i="0" u="none" strike="noStrike" dirty="0">
-                          <a:solidFill>
-                            <a:srgbClr val="000000"/>
-                          </a:solidFill>
-                          <a:effectLst/>
-                          <a:latin typeface="Arial" panose="020B0604020202020204" pitchFamily="34" charset="0"/>
-                          <a:cs typeface="Arial" panose="020B0604020202020204" pitchFamily="34" charset="0"/>
-                        </a:rPr>
-                        <a:t>2037</a:t>
-                      </a:r>
-                    </a:p>
-                  </a:txBody>
-                  <a:tcPr marL="9525" marR="9525" marT="9525" marB="0" anchor="ctr"/>
-                </a:tc>
-                <a:extLst>
-                  <a:ext uri="{0D108BD9-81ED-4DB2-BD59-A6C34878D82A}">
-                    <a16:rowId xmlns:a16="http://schemas.microsoft.com/office/drawing/2014/main" val="706977273"/>
-                  </a:ext>
-                </a:extLst>
-              </a:tr>
-              <a:tr h="205733">
-                <a:tc>
-                  <a:txBody>
-                    <a:bodyPr/>
-                    <a:lstStyle/>
-                    <a:p>
-                      <a:pPr algn="ctr" fontAlgn="b">
-                        <a:buNone/>
-                      </a:pPr>
-                      <a:r>
-                        <a:rPr lang="en-FR" sz="1000" b="0" u="none" strike="noStrike" dirty="0">
-                          <a:solidFill>
-                            <a:srgbClr val="000000"/>
-                          </a:solidFill>
-                          <a:effectLst/>
-                          <a:latin typeface="Arial" panose="020B0604020202020204" pitchFamily="34" charset="0"/>
-                          <a:cs typeface="Arial" panose="020B0604020202020204" pitchFamily="34" charset="0"/>
-                        </a:rPr>
-                        <a:t>Bylvay</a:t>
-                      </a:r>
-                      <a:endParaRPr lang="en-FR" sz="1000" b="0" i="0" u="none" strike="noStrike" dirty="0">
-                        <a:solidFill>
-                          <a:srgbClr val="000000"/>
-                        </a:solidFill>
-                        <a:effectLst/>
-                        <a:latin typeface="Arial" panose="020B0604020202020204" pitchFamily="34" charset="0"/>
-                        <a:cs typeface="Arial" panose="020B0604020202020204" pitchFamily="34" charset="0"/>
-                      </a:endParaRPr>
-                    </a:p>
-                  </a:txBody>
-                  <a:tcPr marL="9525" marR="9525" marT="9525" marB="0" anchor="ctr"/>
-                </a:tc>
-                <a:tc>
-                  <a:txBody>
-                    <a:bodyPr/>
-                    <a:lstStyle/>
-                    <a:p>
-                      <a:pPr algn="ctr" fontAlgn="b">
-                        <a:buNone/>
-                      </a:pPr>
-                      <a:r>
-                        <a:rPr lang="en-FR" sz="1000" b="0" u="none" strike="noStrike">
-                          <a:solidFill>
-                            <a:srgbClr val="000000"/>
-                          </a:solidFill>
-                          <a:effectLst/>
-                          <a:latin typeface="Arial" panose="020B0604020202020204" pitchFamily="34" charset="0"/>
-                          <a:cs typeface="Arial" panose="020B0604020202020204" pitchFamily="34" charset="0"/>
-                        </a:rPr>
-                        <a:t>Rare Diseases</a:t>
-                      </a:r>
-                      <a:endParaRPr lang="en-FR" sz="1000" b="0" i="0" u="none" strike="noStrike">
-                        <a:solidFill>
-                          <a:srgbClr val="000000"/>
-                        </a:solidFill>
-                        <a:effectLst/>
-                        <a:latin typeface="Arial" panose="020B0604020202020204" pitchFamily="34" charset="0"/>
-                        <a:cs typeface="Arial" panose="020B0604020202020204" pitchFamily="34" charset="0"/>
-                      </a:endParaRPr>
-                    </a:p>
-                  </a:txBody>
-                  <a:tcPr marL="9525" marR="9525" marT="9525" marB="0" anchor="ctr"/>
-                </a:tc>
-                <a:tc>
-                  <a:txBody>
-                    <a:bodyPr/>
-                    <a:lstStyle/>
-                    <a:p>
-                      <a:pPr algn="ctr" fontAlgn="b">
-                        <a:buNone/>
-                      </a:pPr>
-                      <a:r>
-                        <a:rPr lang="en-FR" sz="1000" b="0" u="none" strike="noStrike">
-                          <a:solidFill>
-                            <a:srgbClr val="000000"/>
-                          </a:solidFill>
-                          <a:effectLst/>
-                          <a:latin typeface="Arial" panose="020B0604020202020204" pitchFamily="34" charset="0"/>
-                          <a:cs typeface="Arial" panose="020B0604020202020204" pitchFamily="34" charset="0"/>
-                        </a:rPr>
-                        <a:t> $            180 </a:t>
-                      </a:r>
-                      <a:endParaRPr lang="en-FR" sz="1000" b="0" i="0" u="none" strike="noStrike">
-                        <a:solidFill>
-                          <a:srgbClr val="000000"/>
-                        </a:solidFill>
-                        <a:effectLst/>
-                        <a:latin typeface="Arial" panose="020B0604020202020204" pitchFamily="34" charset="0"/>
-                        <a:cs typeface="Arial" panose="020B0604020202020204" pitchFamily="34" charset="0"/>
-                      </a:endParaRPr>
-                    </a:p>
-                  </a:txBody>
-                  <a:tcPr marL="9525" marR="9525" marT="9525" marB="0" anchor="ctr"/>
-                </a:tc>
-                <a:tc>
-                  <a:txBody>
-                    <a:bodyPr/>
-                    <a:lstStyle/>
-                    <a:p>
-                      <a:pPr algn="ctr" fontAlgn="b">
-                        <a:buNone/>
-                      </a:pPr>
-                      <a:r>
-                        <a:rPr lang="en-FR" sz="1000" b="0" u="none" strike="noStrike" dirty="0">
-                          <a:solidFill>
-                            <a:srgbClr val="000000"/>
-                          </a:solidFill>
-                          <a:effectLst/>
-                          <a:latin typeface="Arial" panose="020B0604020202020204" pitchFamily="34" charset="0"/>
-                          <a:cs typeface="Arial" panose="020B0604020202020204" pitchFamily="34" charset="0"/>
-                        </a:rPr>
-                        <a:t>36.3%</a:t>
-                      </a:r>
-                      <a:endParaRPr lang="en-FR" sz="1000" b="0" i="0" u="none" strike="noStrike" dirty="0">
-                        <a:solidFill>
-                          <a:srgbClr val="000000"/>
-                        </a:solidFill>
-                        <a:effectLst/>
-                        <a:latin typeface="Arial" panose="020B0604020202020204" pitchFamily="34" charset="0"/>
-                        <a:cs typeface="Arial" panose="020B0604020202020204" pitchFamily="34" charset="0"/>
-                      </a:endParaRPr>
-                    </a:p>
-                  </a:txBody>
-                  <a:tcPr marL="9525" marR="9525" marT="9525" marB="0" anchor="ctr"/>
-                </a:tc>
-                <a:tc>
-                  <a:txBody>
-                    <a:bodyPr/>
-                    <a:lstStyle/>
-                    <a:p>
-                      <a:pPr algn="ctr" fontAlgn="b">
-                        <a:buNone/>
-                      </a:pPr>
-                      <a:r>
-                        <a:rPr lang="en-FR" sz="1000" b="0" i="0" u="none" strike="noStrike" dirty="0">
-                          <a:solidFill>
-                            <a:srgbClr val="000000"/>
-                          </a:solidFill>
-                          <a:effectLst/>
-                          <a:latin typeface="Arial" panose="020B0604020202020204" pitchFamily="34" charset="0"/>
-                          <a:cs typeface="Arial" panose="020B0604020202020204" pitchFamily="34" charset="0"/>
-                        </a:rPr>
-                        <a:t>SM</a:t>
-                      </a:r>
-                    </a:p>
-                  </a:txBody>
-                  <a:tcPr marL="9525" marR="9525" marT="9525" marB="0" anchor="ctr"/>
-                </a:tc>
-                <a:tc>
-                  <a:txBody>
-                    <a:bodyPr/>
-                    <a:lstStyle/>
-                    <a:p>
-                      <a:pPr algn="ctr" fontAlgn="b">
-                        <a:buNone/>
-                      </a:pPr>
-                      <a:r>
-                        <a:rPr lang="en-FR" sz="1000" b="0" i="0" u="none" strike="noStrike" dirty="0">
-                          <a:solidFill>
-                            <a:srgbClr val="000000"/>
-                          </a:solidFill>
-                          <a:effectLst/>
-                          <a:latin typeface="Arial" panose="020B0604020202020204" pitchFamily="34" charset="0"/>
-                          <a:cs typeface="Arial" panose="020B0604020202020204" pitchFamily="34" charset="0"/>
-                        </a:rPr>
-                        <a:t>2039</a:t>
-                      </a:r>
-                    </a:p>
-                  </a:txBody>
-                  <a:tcPr marL="9525" marR="9525" marT="9525" marB="0" anchor="ctr"/>
-                </a:tc>
-                <a:extLst>
-                  <a:ext uri="{0D108BD9-81ED-4DB2-BD59-A6C34878D82A}">
-                    <a16:rowId xmlns:a16="http://schemas.microsoft.com/office/drawing/2014/main" val="215480271"/>
-                  </a:ext>
-                </a:extLst>
-              </a:tr>
-              <a:tr h="205733">
-                <a:tc>
-                  <a:txBody>
-                    <a:bodyPr/>
-                    <a:lstStyle/>
-                    <a:p>
-                      <a:pPr algn="ctr" fontAlgn="b">
-                        <a:buNone/>
-                      </a:pPr>
-                      <a:r>
-                        <a:rPr lang="en-FR" sz="1000" b="0" u="none" strike="noStrike" dirty="0">
-                          <a:solidFill>
-                            <a:srgbClr val="000000"/>
-                          </a:solidFill>
-                          <a:effectLst/>
-                          <a:latin typeface="Arial" panose="020B0604020202020204" pitchFamily="34" charset="0"/>
-                          <a:cs typeface="Arial" panose="020B0604020202020204" pitchFamily="34" charset="0"/>
-                        </a:rPr>
-                        <a:t>Sohonos</a:t>
-                      </a:r>
-                      <a:endParaRPr lang="en-FR" sz="1000" b="0" i="0" u="none" strike="noStrike" dirty="0">
-                        <a:solidFill>
-                          <a:srgbClr val="000000"/>
-                        </a:solidFill>
-                        <a:effectLst/>
-                        <a:latin typeface="Arial" panose="020B0604020202020204" pitchFamily="34" charset="0"/>
-                        <a:cs typeface="Arial" panose="020B0604020202020204" pitchFamily="34" charset="0"/>
-                      </a:endParaRPr>
-                    </a:p>
-                  </a:txBody>
-                  <a:tcPr marL="9525" marR="9525" marT="9525" marB="0" anchor="ctr"/>
-                </a:tc>
-                <a:tc>
-                  <a:txBody>
-                    <a:bodyPr/>
-                    <a:lstStyle/>
-                    <a:p>
-                      <a:pPr algn="ctr" fontAlgn="b">
-                        <a:buNone/>
-                      </a:pPr>
-                      <a:r>
-                        <a:rPr lang="en-FR" sz="1000" b="0" u="none" strike="noStrike">
-                          <a:solidFill>
-                            <a:srgbClr val="000000"/>
-                          </a:solidFill>
-                          <a:effectLst/>
-                          <a:latin typeface="Arial" panose="020B0604020202020204" pitchFamily="34" charset="0"/>
-                          <a:cs typeface="Arial" panose="020B0604020202020204" pitchFamily="34" charset="0"/>
-                        </a:rPr>
-                        <a:t>Rare Diseases</a:t>
-                      </a:r>
-                      <a:endParaRPr lang="en-FR" sz="1000" b="0" i="0" u="none" strike="noStrike">
-                        <a:solidFill>
-                          <a:srgbClr val="000000"/>
-                        </a:solidFill>
-                        <a:effectLst/>
-                        <a:latin typeface="Arial" panose="020B0604020202020204" pitchFamily="34" charset="0"/>
-                        <a:cs typeface="Arial" panose="020B0604020202020204" pitchFamily="34" charset="0"/>
-                      </a:endParaRPr>
-                    </a:p>
-                  </a:txBody>
-                  <a:tcPr marL="9525" marR="9525" marT="9525" marB="0" anchor="ctr"/>
-                </a:tc>
-                <a:tc>
-                  <a:txBody>
-                    <a:bodyPr/>
-                    <a:lstStyle/>
-                    <a:p>
-                      <a:pPr algn="ctr" fontAlgn="b">
-                        <a:buNone/>
-                      </a:pPr>
-                      <a:r>
-                        <a:rPr lang="en-FR" sz="1000" b="0" u="none" strike="noStrike">
-                          <a:solidFill>
-                            <a:srgbClr val="000000"/>
-                          </a:solidFill>
-                          <a:effectLst/>
-                          <a:latin typeface="Arial" panose="020B0604020202020204" pitchFamily="34" charset="0"/>
-                          <a:cs typeface="Arial" panose="020B0604020202020204" pitchFamily="34" charset="0"/>
-                        </a:rPr>
-                        <a:t> $              21 </a:t>
-                      </a:r>
-                      <a:endParaRPr lang="en-FR" sz="1000" b="0" i="0" u="none" strike="noStrike">
-                        <a:solidFill>
-                          <a:srgbClr val="000000"/>
-                        </a:solidFill>
-                        <a:effectLst/>
-                        <a:latin typeface="Arial" panose="020B0604020202020204" pitchFamily="34" charset="0"/>
-                        <a:cs typeface="Arial" panose="020B0604020202020204" pitchFamily="34" charset="0"/>
-                      </a:endParaRPr>
-                    </a:p>
-                  </a:txBody>
-                  <a:tcPr marL="9525" marR="9525" marT="9525" marB="0" anchor="ctr"/>
-                </a:tc>
-                <a:tc>
-                  <a:txBody>
-                    <a:bodyPr/>
-                    <a:lstStyle/>
-                    <a:p>
-                      <a:pPr algn="ctr" fontAlgn="b">
-                        <a:buNone/>
-                      </a:pPr>
-                      <a:r>
-                        <a:rPr lang="en-FR" sz="1000" b="0" u="none" strike="noStrike">
-                          <a:solidFill>
-                            <a:srgbClr val="000000"/>
-                          </a:solidFill>
-                          <a:effectLst/>
-                          <a:latin typeface="Arial" panose="020B0604020202020204" pitchFamily="34" charset="0"/>
-                          <a:cs typeface="Arial" panose="020B0604020202020204" pitchFamily="34" charset="0"/>
-                        </a:rPr>
-                        <a:t>0.1%</a:t>
-                      </a:r>
-                      <a:endParaRPr lang="en-FR" sz="1000" b="0" i="0" u="none" strike="noStrike">
-                        <a:solidFill>
-                          <a:srgbClr val="000000"/>
-                        </a:solidFill>
-                        <a:effectLst/>
-                        <a:latin typeface="Arial" panose="020B0604020202020204" pitchFamily="34" charset="0"/>
-                        <a:cs typeface="Arial" panose="020B0604020202020204" pitchFamily="34" charset="0"/>
-                      </a:endParaRPr>
-                    </a:p>
-                  </a:txBody>
-                  <a:tcPr marL="9525" marR="9525" marT="9525" marB="0" anchor="ctr"/>
-                </a:tc>
-                <a:tc>
-                  <a:txBody>
-                    <a:bodyPr/>
-                    <a:lstStyle/>
-                    <a:p>
-                      <a:pPr algn="ctr" fontAlgn="b">
-                        <a:buNone/>
-                      </a:pPr>
-                      <a:r>
-                        <a:rPr lang="en-FR" sz="1000" b="0" i="0" u="none" strike="noStrike" dirty="0">
-                          <a:solidFill>
-                            <a:srgbClr val="000000"/>
-                          </a:solidFill>
-                          <a:effectLst/>
-                          <a:latin typeface="Arial" panose="020B0604020202020204" pitchFamily="34" charset="0"/>
-                          <a:cs typeface="Arial" panose="020B0604020202020204" pitchFamily="34" charset="0"/>
-                        </a:rPr>
-                        <a:t>SM</a:t>
-                      </a:r>
-                    </a:p>
-                  </a:txBody>
-                  <a:tcPr marL="9525" marR="9525" marT="9525" marB="0" anchor="ctr"/>
-                </a:tc>
-                <a:tc>
-                  <a:txBody>
-                    <a:bodyPr/>
-                    <a:lstStyle/>
-                    <a:p>
-                      <a:pPr algn="ctr" fontAlgn="b">
-                        <a:buNone/>
-                      </a:pPr>
-                      <a:r>
-                        <a:rPr lang="en-FR" sz="1000" b="0" i="0" u="none" strike="noStrike" dirty="0">
-                          <a:solidFill>
-                            <a:srgbClr val="000000"/>
-                          </a:solidFill>
-                          <a:effectLst/>
-                          <a:latin typeface="Arial" panose="020B0604020202020204" pitchFamily="34" charset="0"/>
-                          <a:cs typeface="Arial" panose="020B0604020202020204" pitchFamily="34" charset="0"/>
-                        </a:rPr>
-                        <a:t>2038</a:t>
-                      </a:r>
-                    </a:p>
-                  </a:txBody>
-                  <a:tcPr marL="9525" marR="9525" marT="9525" marB="0" anchor="ctr"/>
-                </a:tc>
-                <a:extLst>
-                  <a:ext uri="{0D108BD9-81ED-4DB2-BD59-A6C34878D82A}">
-                    <a16:rowId xmlns:a16="http://schemas.microsoft.com/office/drawing/2014/main" val="564204970"/>
-                  </a:ext>
-                </a:extLst>
-              </a:tr>
-              <a:tr h="205733">
-                <a:tc>
-                  <a:txBody>
-                    <a:bodyPr/>
-                    <a:lstStyle/>
-                    <a:p>
-                      <a:pPr algn="ctr" fontAlgn="b">
-                        <a:buNone/>
-                      </a:pPr>
-                      <a:r>
-                        <a:rPr lang="en-FR" sz="1000" b="0" u="none" strike="noStrike" dirty="0">
-                          <a:solidFill>
-                            <a:srgbClr val="000000"/>
-                          </a:solidFill>
-                          <a:effectLst/>
-                          <a:latin typeface="Arial" panose="020B0604020202020204" pitchFamily="34" charset="0"/>
-                          <a:cs typeface="Arial" panose="020B0604020202020204" pitchFamily="34" charset="0"/>
-                        </a:rPr>
-                        <a:t>Dysport</a:t>
-                      </a:r>
-                      <a:endParaRPr lang="en-FR" sz="1000" b="0" i="0" u="none" strike="noStrike" dirty="0">
-                        <a:solidFill>
-                          <a:srgbClr val="000000"/>
-                        </a:solidFill>
-                        <a:effectLst/>
-                        <a:latin typeface="Arial" panose="020B0604020202020204" pitchFamily="34" charset="0"/>
-                        <a:cs typeface="Arial" panose="020B0604020202020204" pitchFamily="34" charset="0"/>
-                      </a:endParaRPr>
-                    </a:p>
-                  </a:txBody>
-                  <a:tcPr marL="9525" marR="9525" marT="9525" marB="0" anchor="ctr"/>
-                </a:tc>
-                <a:tc>
-                  <a:txBody>
-                    <a:bodyPr/>
-                    <a:lstStyle/>
-                    <a:p>
-                      <a:pPr algn="ctr" fontAlgn="b">
-                        <a:buNone/>
-                      </a:pPr>
-                      <a:r>
-                        <a:rPr lang="en-FR" sz="1000" b="0" u="none" strike="noStrike">
-                          <a:solidFill>
-                            <a:srgbClr val="000000"/>
-                          </a:solidFill>
-                          <a:effectLst/>
-                          <a:latin typeface="Arial" panose="020B0604020202020204" pitchFamily="34" charset="0"/>
-                          <a:cs typeface="Arial" panose="020B0604020202020204" pitchFamily="34" charset="0"/>
-                        </a:rPr>
-                        <a:t>Neurosciences</a:t>
-                      </a:r>
-                      <a:endParaRPr lang="en-FR" sz="1000" b="0" i="0" u="none" strike="noStrike">
-                        <a:solidFill>
-                          <a:srgbClr val="000000"/>
-                        </a:solidFill>
-                        <a:effectLst/>
-                        <a:latin typeface="Arial" panose="020B0604020202020204" pitchFamily="34" charset="0"/>
-                        <a:cs typeface="Arial" panose="020B0604020202020204" pitchFamily="34" charset="0"/>
-                      </a:endParaRPr>
-                    </a:p>
-                  </a:txBody>
-                  <a:tcPr marL="9525" marR="9525" marT="9525" marB="0" anchor="ctr"/>
-                </a:tc>
-                <a:tc>
-                  <a:txBody>
-                    <a:bodyPr/>
-                    <a:lstStyle/>
-                    <a:p>
-                      <a:pPr algn="ctr" fontAlgn="b">
-                        <a:buNone/>
-                      </a:pPr>
-                      <a:r>
-                        <a:rPr lang="en-FR" sz="1000" b="0" u="none" strike="noStrike">
-                          <a:solidFill>
-                            <a:srgbClr val="000000"/>
-                          </a:solidFill>
-                          <a:effectLst/>
-                          <a:latin typeface="Arial" panose="020B0604020202020204" pitchFamily="34" charset="0"/>
-                          <a:cs typeface="Arial" panose="020B0604020202020204" pitchFamily="34" charset="0"/>
-                        </a:rPr>
-                        <a:t> $            734 </a:t>
-                      </a:r>
-                      <a:endParaRPr lang="en-FR" sz="1000" b="0" i="0" u="none" strike="noStrike">
-                        <a:solidFill>
-                          <a:srgbClr val="000000"/>
-                        </a:solidFill>
-                        <a:effectLst/>
-                        <a:latin typeface="Arial" panose="020B0604020202020204" pitchFamily="34" charset="0"/>
-                        <a:cs typeface="Arial" panose="020B0604020202020204" pitchFamily="34" charset="0"/>
-                      </a:endParaRPr>
-                    </a:p>
-                  </a:txBody>
-                  <a:tcPr marL="9525" marR="9525" marT="9525" marB="0" anchor="ctr"/>
-                </a:tc>
-                <a:tc>
-                  <a:txBody>
-                    <a:bodyPr/>
-                    <a:lstStyle/>
-                    <a:p>
-                      <a:pPr algn="ctr" fontAlgn="b">
-                        <a:buNone/>
-                      </a:pPr>
-                      <a:r>
-                        <a:rPr lang="en-FR" sz="1000" b="0" u="none" strike="noStrike">
-                          <a:solidFill>
-                            <a:srgbClr val="000000"/>
-                          </a:solidFill>
-                          <a:effectLst/>
-                          <a:latin typeface="Arial" panose="020B0604020202020204" pitchFamily="34" charset="0"/>
-                          <a:cs typeface="Arial" panose="020B0604020202020204" pitchFamily="34" charset="0"/>
-                        </a:rPr>
-                        <a:t>9.7%</a:t>
-                      </a:r>
-                      <a:endParaRPr lang="en-FR" sz="1000" b="0" i="0" u="none" strike="noStrike">
                         <a:solidFill>
                           <a:srgbClr val="000000"/>
                         </a:solidFill>
@@ -9117,6 +8763,41 @@
           </a:graphicData>
         </a:graphic>
       </p:graphicFrame>
+      <p:sp>
+        <p:nvSpPr>
+          <p:cNvPr id="33" name="TextBox 32">
+            <a:extLst>
+              <a:ext uri="{FF2B5EF4-FFF2-40B4-BE49-F238E27FC236}">
+                <a16:creationId xmlns:a16="http://schemas.microsoft.com/office/drawing/2014/main" id="{BA9D6793-9232-8911-0D97-59C86A77114B}"/>
+              </a:ext>
+            </a:extLst>
+          </p:cNvPr>
+          <p:cNvSpPr txBox="1"/>
+          <p:nvPr/>
+        </p:nvSpPr>
+        <p:spPr>
+          <a:xfrm>
+            <a:off x="10452312" y="6564260"/>
+            <a:ext cx="1654620" cy="261610"/>
+          </a:xfrm>
+          <a:prstGeom prst="rect">
+            <a:avLst/>
+          </a:prstGeom>
+          <a:noFill/>
+        </p:spPr>
+        <p:txBody>
+          <a:bodyPr wrap="none" rtlCol="0">
+            <a:spAutoFit/>
+          </a:bodyPr>
+          <a:lstStyle/>
+          <a:p>
+            <a:r>
+              <a:rPr lang="en-AU" sz="1100" i="1" dirty="0"/>
+              <a:t>* Licensed from Exelixis.</a:t>
+            </a:r>
+          </a:p>
+        </p:txBody>
+      </p:sp>
     </p:spTree>
     <p:extLst>
       <p:ext uri="{BB962C8B-B14F-4D97-AF65-F5344CB8AC3E}">
@@ -9378,10 +9059,10 @@
       </p:sp>
       <p:sp>
         <p:nvSpPr>
-          <p:cNvPr id="11" name="Rectangle 10">
+          <p:cNvPr id="15" name="Rectangle 14">
             <a:extLst>
               <a:ext uri="{FF2B5EF4-FFF2-40B4-BE49-F238E27FC236}">
-                <a16:creationId xmlns:a16="http://schemas.microsoft.com/office/drawing/2014/main" id="{F0C5C1B1-901C-657B-7FAA-AA9A5CD1BF22}"/>
+                <a16:creationId xmlns:a16="http://schemas.microsoft.com/office/drawing/2014/main" id="{B37309D6-F235-4153-66C5-EABAD384377D}"/>
               </a:ext>
             </a:extLst>
           </p:cNvPr>
@@ -9390,7 +9071,7 @@
         </p:nvSpPr>
         <p:spPr>
           <a:xfrm>
-            <a:off x="451104" y="1447671"/>
+            <a:off x="526950" y="2380916"/>
             <a:ext cx="2900922" cy="45719"/>
           </a:xfrm>
           <a:prstGeom prst="rect">
@@ -9430,10 +9111,10 @@
       </p:sp>
       <p:sp>
         <p:nvSpPr>
-          <p:cNvPr id="13" name="TextBox 12">
+          <p:cNvPr id="16" name="TextBox 15">
             <a:extLst>
               <a:ext uri="{FF2B5EF4-FFF2-40B4-BE49-F238E27FC236}">
-                <a16:creationId xmlns:a16="http://schemas.microsoft.com/office/drawing/2014/main" id="{FFDFB974-72E5-20EC-A8D8-06F57E7DB71C}"/>
+                <a16:creationId xmlns:a16="http://schemas.microsoft.com/office/drawing/2014/main" id="{D6943AD7-58A9-9ECC-E9B3-78E67C6D31AD}"/>
               </a:ext>
             </a:extLst>
           </p:cNvPr>
@@ -9442,8 +9123,8 @@
         </p:nvSpPr>
         <p:spPr>
           <a:xfrm>
-            <a:off x="375258" y="1101198"/>
-            <a:ext cx="5425973" cy="369332"/>
+            <a:off x="451104" y="2034443"/>
+            <a:ext cx="1183978" cy="369332"/>
           </a:xfrm>
           <a:prstGeom prst="rect">
             <a:avLst/>
@@ -9457,1021 +9138,22 @@
           <a:lstStyle/>
           <a:p>
             <a:r>
-              <a:rPr lang="en-AU" b="1" dirty="0" err="1">
-                <a:solidFill>
-                  <a:srgbClr val="163B5A"/>
-                </a:solidFill>
-              </a:rPr>
-              <a:t>MoA</a:t>
-            </a:r>
-            <a:r>
               <a:rPr lang="en-AU" b="1" dirty="0">
                 <a:solidFill>
                   <a:srgbClr val="163B5A"/>
                 </a:solidFill>
               </a:rPr>
-              <a:t> and Indications for Market and Competition</a:t>
+              <a:t>Oncology</a:t>
             </a:r>
           </a:p>
         </p:txBody>
       </p:sp>
-      <p:graphicFrame>
-        <p:nvGraphicFramePr>
-          <p:cNvPr id="14" name="Table 13">
+      <p:sp>
+        <p:nvSpPr>
+          <p:cNvPr id="17" name="Rectangle 16">
             <a:extLst>
               <a:ext uri="{FF2B5EF4-FFF2-40B4-BE49-F238E27FC236}">
-                <a16:creationId xmlns:a16="http://schemas.microsoft.com/office/drawing/2014/main" id="{370DBFD2-2318-2FB9-7C42-459C18A84859}"/>
-              </a:ext>
-            </a:extLst>
-          </p:cNvPr>
-          <p:cNvGraphicFramePr>
-            <a:graphicFrameLocks noGrp="1"/>
-          </p:cNvGraphicFramePr>
-          <p:nvPr>
-            <p:extLst>
-              <p:ext uri="{D42A27DB-BD31-4B8C-83A1-F6EECF244321}">
-                <p14:modId xmlns:p14="http://schemas.microsoft.com/office/powerpoint/2010/main" val="191735135"/>
-              </p:ext>
-            </p:extLst>
-          </p:nvPr>
-        </p:nvGraphicFramePr>
-        <p:xfrm>
-          <a:off x="451104" y="1620715"/>
-          <a:ext cx="11289791" cy="1594485"/>
-        </p:xfrm>
-        <a:graphic>
-          <a:graphicData uri="http://schemas.openxmlformats.org/drawingml/2006/table">
-            <a:tbl>
-              <a:tblPr firstRow="1" bandRow="1">
-                <a:tableStyleId>{6E25E649-3F16-4E02-A733-19D2CDBF48F0}</a:tableStyleId>
-              </a:tblPr>
-              <a:tblGrid>
-                <a:gridCol w="1935981">
-                  <a:extLst>
-                    <a:ext uri="{9D8B030D-6E8A-4147-A177-3AD203B41FA5}">
-                      <a16:colId xmlns:a16="http://schemas.microsoft.com/office/drawing/2014/main" val="4200776620"/>
-                    </a:ext>
-                  </a:extLst>
-                </a:gridCol>
-                <a:gridCol w="2718611">
-                  <a:extLst>
-                    <a:ext uri="{9D8B030D-6E8A-4147-A177-3AD203B41FA5}">
-                      <a16:colId xmlns:a16="http://schemas.microsoft.com/office/drawing/2014/main" val="3962167202"/>
-                    </a:ext>
-                  </a:extLst>
-                </a:gridCol>
-                <a:gridCol w="6635199">
-                  <a:extLst>
-                    <a:ext uri="{9D8B030D-6E8A-4147-A177-3AD203B41FA5}">
-                      <a16:colId xmlns:a16="http://schemas.microsoft.com/office/drawing/2014/main" val="1114885578"/>
-                    </a:ext>
-                  </a:extLst>
-                </a:gridCol>
-              </a:tblGrid>
-              <a:tr h="125978">
-                <a:tc>
-                  <a:txBody>
-                    <a:bodyPr/>
-                    <a:lstStyle/>
-                    <a:p>
-                      <a:pPr algn="ctr" fontAlgn="ctr">
-                        <a:buNone/>
-                      </a:pPr>
-                      <a:r>
-                        <a:rPr lang="en-FR" sz="1100" b="1" u="none" strike="noStrike" dirty="0">
-                          <a:solidFill>
-                            <a:srgbClr val="FFFFFF"/>
-                          </a:solidFill>
-                          <a:effectLst/>
-                        </a:rPr>
-                        <a:t>TA</a:t>
-                      </a:r>
-                      <a:endParaRPr lang="en-FR" sz="1100" b="1" i="0" u="none" strike="noStrike" dirty="0">
-                        <a:solidFill>
-                          <a:srgbClr val="FFFFFF"/>
-                        </a:solidFill>
-                        <a:effectLst/>
-                        <a:latin typeface="Carlito"/>
-                      </a:endParaRPr>
-                    </a:p>
-                  </a:txBody>
-                  <a:tcPr marL="9525" marR="9525" marT="9525" marB="0" anchor="ctr"/>
-                </a:tc>
-                <a:tc>
-                  <a:txBody>
-                    <a:bodyPr/>
-                    <a:lstStyle/>
-                    <a:p>
-                      <a:pPr algn="ctr" fontAlgn="ctr">
-                        <a:buNone/>
-                      </a:pPr>
-                      <a:r>
-                        <a:rPr lang="en-FR" sz="1100" b="1" u="none" strike="noStrike" dirty="0">
-                          <a:solidFill>
-                            <a:srgbClr val="FFFFFF"/>
-                          </a:solidFill>
-                          <a:effectLst/>
-                        </a:rPr>
-                        <a:t>Asset (Product / Pipeline)</a:t>
-                      </a:r>
-                      <a:endParaRPr lang="en-FR" sz="1100" b="1" i="0" u="none" strike="noStrike" dirty="0">
-                        <a:solidFill>
-                          <a:srgbClr val="FFFFFF"/>
-                        </a:solidFill>
-                        <a:effectLst/>
-                        <a:latin typeface="Carlito"/>
-                      </a:endParaRPr>
-                    </a:p>
-                  </a:txBody>
-                  <a:tcPr marL="9525" marR="9525" marT="9525" marB="0" anchor="ctr"/>
-                </a:tc>
-                <a:tc>
-                  <a:txBody>
-                    <a:bodyPr/>
-                    <a:lstStyle/>
-                    <a:p>
-                      <a:pPr algn="ctr" fontAlgn="ctr">
-                        <a:buNone/>
-                      </a:pPr>
-                      <a:r>
-                        <a:rPr lang="en-FR" sz="1100" b="1" u="none" strike="noStrike" dirty="0">
-                          <a:solidFill>
-                            <a:srgbClr val="FFFFFF"/>
-                          </a:solidFill>
-                          <a:effectLst/>
-                        </a:rPr>
-                        <a:t>MoA / Market</a:t>
-                      </a:r>
-                      <a:endParaRPr lang="en-FR" sz="1100" b="1" i="0" u="none" strike="noStrike" dirty="0">
-                        <a:solidFill>
-                          <a:srgbClr val="FFFFFF"/>
-                        </a:solidFill>
-                        <a:effectLst/>
-                        <a:latin typeface="Carlito"/>
-                      </a:endParaRPr>
-                    </a:p>
-                  </a:txBody>
-                  <a:tcPr marL="9525" marR="9525" marT="9525" marB="0" anchor="ctr"/>
-                </a:tc>
-                <a:extLst>
-                  <a:ext uri="{0D108BD9-81ED-4DB2-BD59-A6C34878D82A}">
-                    <a16:rowId xmlns:a16="http://schemas.microsoft.com/office/drawing/2014/main" val="833554430"/>
-                  </a:ext>
-                </a:extLst>
-              </a:tr>
-              <a:tr h="118104">
-                <a:tc>
-                  <a:txBody>
-                    <a:bodyPr/>
-                    <a:lstStyle/>
-                    <a:p>
-                      <a:pPr marL="0" marR="0" lvl="0" indent="0" algn="ctr" defTabSz="914400" rtl="0" eaLnBrk="1" fontAlgn="b" latinLnBrk="0" hangingPunct="1">
-                        <a:lnSpc>
-                          <a:spcPct val="100000"/>
-                        </a:lnSpc>
-                        <a:spcBef>
-                          <a:spcPts val="0"/>
-                        </a:spcBef>
-                        <a:spcAft>
-                          <a:spcPts val="0"/>
-                        </a:spcAft>
-                        <a:buClrTx/>
-                        <a:buSzTx/>
-                        <a:buFontTx/>
-                        <a:buNone/>
-                        <a:tabLst/>
-                        <a:defRPr/>
-                      </a:pPr>
-                      <a:r>
-                        <a:rPr kumimoji="0" lang="en-FR" sz="1100" b="0" i="0" u="none" strike="noStrike" kern="1200" cap="none" spc="0" normalizeH="0" baseline="0" noProof="0" dirty="0">
-                          <a:ln>
-                            <a:noFill/>
-                          </a:ln>
-                          <a:solidFill>
-                            <a:prstClr val="black"/>
-                          </a:solidFill>
-                          <a:effectLst/>
-                          <a:uLnTx/>
-                          <a:uFillTx/>
-                          <a:latin typeface="Aptos" panose="02110004020202020204"/>
-                          <a:ea typeface="+mn-ea"/>
-                          <a:cs typeface="+mn-cs"/>
-                        </a:rPr>
-                        <a:t>Oncology</a:t>
-                      </a:r>
-                      <a:endParaRPr kumimoji="0" lang="en-FR" sz="1100" b="0" i="0" u="none" strike="noStrike" kern="1200" cap="none" spc="0" normalizeH="0" baseline="0" noProof="0" dirty="0">
-                        <a:ln>
-                          <a:noFill/>
-                        </a:ln>
-                        <a:solidFill>
-                          <a:prstClr val="black"/>
-                        </a:solidFill>
-                        <a:effectLst/>
-                        <a:uLnTx/>
-                        <a:uFillTx/>
-                        <a:latin typeface="Carlito"/>
-                        <a:ea typeface="+mn-ea"/>
-                        <a:cs typeface="+mn-cs"/>
-                      </a:endParaRPr>
-                    </a:p>
-                  </a:txBody>
-                  <a:tcPr marL="9525" marR="9525" marT="9525" marB="0" anchor="b"/>
-                </a:tc>
-                <a:tc>
-                  <a:txBody>
-                    <a:bodyPr/>
-                    <a:lstStyle/>
-                    <a:p>
-                      <a:pPr algn="ctr" fontAlgn="b">
-                        <a:buNone/>
-                      </a:pPr>
-                      <a:r>
-                        <a:rPr lang="en-FR" sz="1000" b="0" u="none" strike="noStrike" dirty="0">
-                          <a:solidFill>
-                            <a:srgbClr val="000000"/>
-                          </a:solidFill>
-                          <a:effectLst/>
-                          <a:latin typeface="Arial" panose="020B0604020202020204" pitchFamily="34" charset="0"/>
-                          <a:cs typeface="Arial" panose="020B0604020202020204" pitchFamily="34" charset="0"/>
-                        </a:rPr>
-                        <a:t>Somatuline</a:t>
-                      </a:r>
-                      <a:endParaRPr lang="en-FR" sz="1000" b="0" i="0" u="none" strike="noStrike" dirty="0">
-                        <a:solidFill>
-                          <a:srgbClr val="000000"/>
-                        </a:solidFill>
-                        <a:effectLst/>
-                        <a:latin typeface="Arial" panose="020B0604020202020204" pitchFamily="34" charset="0"/>
-                        <a:cs typeface="Arial" panose="020B0604020202020204" pitchFamily="34" charset="0"/>
-                      </a:endParaRPr>
-                    </a:p>
-                  </a:txBody>
-                  <a:tcPr marL="9525" marR="9525" marT="9525" marB="0" anchor="ctr"/>
-                </a:tc>
-                <a:tc>
-                  <a:txBody>
-                    <a:bodyPr/>
-                    <a:lstStyle/>
-                    <a:p>
-                      <a:pPr marL="0" marR="0" lvl="0" indent="0" algn="ctr" defTabSz="914400" rtl="0" eaLnBrk="1" fontAlgn="b" latinLnBrk="0" hangingPunct="1">
-                        <a:lnSpc>
-                          <a:spcPct val="100000"/>
-                        </a:lnSpc>
-                        <a:spcBef>
-                          <a:spcPts val="0"/>
-                        </a:spcBef>
-                        <a:spcAft>
-                          <a:spcPts val="0"/>
-                        </a:spcAft>
-                        <a:buClrTx/>
-                        <a:buSzTx/>
-                        <a:buFontTx/>
-                        <a:buNone/>
-                        <a:tabLst/>
-                        <a:defRPr/>
-                      </a:pPr>
-                      <a:r>
-                        <a:rPr lang="en-FR" sz="1100" dirty="0"/>
-                        <a:t>somatostatin analog (peptide)</a:t>
-                      </a:r>
-                    </a:p>
-                  </a:txBody>
-                  <a:tcPr marL="9525" marR="9525" marT="9525" marB="0" anchor="b"/>
-                </a:tc>
-                <a:extLst>
-                  <a:ext uri="{0D108BD9-81ED-4DB2-BD59-A6C34878D82A}">
-                    <a16:rowId xmlns:a16="http://schemas.microsoft.com/office/drawing/2014/main" val="849279326"/>
-                  </a:ext>
-                </a:extLst>
-              </a:tr>
-              <a:tr h="118104">
-                <a:tc>
-                  <a:txBody>
-                    <a:bodyPr/>
-                    <a:lstStyle/>
-                    <a:p>
-                      <a:pPr marL="0" marR="0" lvl="0" indent="0" algn="ctr" defTabSz="914400" rtl="0" eaLnBrk="1" fontAlgn="b" latinLnBrk="0" hangingPunct="1">
-                        <a:lnSpc>
-                          <a:spcPct val="100000"/>
-                        </a:lnSpc>
-                        <a:spcBef>
-                          <a:spcPts val="0"/>
-                        </a:spcBef>
-                        <a:spcAft>
-                          <a:spcPts val="0"/>
-                        </a:spcAft>
-                        <a:buClrTx/>
-                        <a:buSzTx/>
-                        <a:buFontTx/>
-                        <a:buNone/>
-                        <a:tabLst/>
-                        <a:defRPr/>
-                      </a:pPr>
-                      <a:r>
-                        <a:rPr kumimoji="0" lang="en-FR" sz="1100" b="0" i="0" u="none" strike="noStrike" kern="1200" cap="none" spc="0" normalizeH="0" baseline="0" noProof="0">
-                          <a:ln>
-                            <a:noFill/>
-                          </a:ln>
-                          <a:solidFill>
-                            <a:prstClr val="black"/>
-                          </a:solidFill>
-                          <a:effectLst/>
-                          <a:uLnTx/>
-                          <a:uFillTx/>
-                          <a:latin typeface="Aptos" panose="02110004020202020204"/>
-                          <a:ea typeface="+mn-ea"/>
-                          <a:cs typeface="+mn-cs"/>
-                        </a:rPr>
-                        <a:t>Oncology</a:t>
-                      </a:r>
-                      <a:endParaRPr kumimoji="0" lang="en-FR" sz="1100" b="0" i="0" u="none" strike="noStrike" kern="1200" cap="none" spc="0" normalizeH="0" baseline="0" noProof="0" dirty="0">
-                        <a:ln>
-                          <a:noFill/>
-                        </a:ln>
-                        <a:solidFill>
-                          <a:prstClr val="black"/>
-                        </a:solidFill>
-                        <a:effectLst/>
-                        <a:uLnTx/>
-                        <a:uFillTx/>
-                        <a:latin typeface="Carlito"/>
-                        <a:ea typeface="+mn-ea"/>
-                        <a:cs typeface="+mn-cs"/>
-                      </a:endParaRPr>
-                    </a:p>
-                  </a:txBody>
-                  <a:tcPr marL="9525" marR="9525" marT="9525" marB="0" anchor="b"/>
-                </a:tc>
-                <a:tc>
-                  <a:txBody>
-                    <a:bodyPr/>
-                    <a:lstStyle/>
-                    <a:p>
-                      <a:pPr algn="ctr" fontAlgn="b">
-                        <a:buNone/>
-                      </a:pPr>
-                      <a:r>
-                        <a:rPr lang="en-FR" sz="1000" b="0" u="none" strike="noStrike" dirty="0">
-                          <a:solidFill>
-                            <a:srgbClr val="000000"/>
-                          </a:solidFill>
-                          <a:effectLst/>
-                          <a:latin typeface="Arial" panose="020B0604020202020204" pitchFamily="34" charset="0"/>
-                          <a:cs typeface="Arial" panose="020B0604020202020204" pitchFamily="34" charset="0"/>
-                        </a:rPr>
-                        <a:t>Cabometyx</a:t>
-                      </a:r>
-                      <a:endParaRPr lang="en-FR" sz="1000" b="0" i="0" u="none" strike="noStrike" dirty="0">
-                        <a:solidFill>
-                          <a:srgbClr val="000000"/>
-                        </a:solidFill>
-                        <a:effectLst/>
-                        <a:latin typeface="Arial" panose="020B0604020202020204" pitchFamily="34" charset="0"/>
-                        <a:cs typeface="Arial" panose="020B0604020202020204" pitchFamily="34" charset="0"/>
-                      </a:endParaRPr>
-                    </a:p>
-                  </a:txBody>
-                  <a:tcPr marL="9525" marR="9525" marT="9525" marB="0" anchor="ctr"/>
-                </a:tc>
-                <a:tc>
-                  <a:txBody>
-                    <a:bodyPr/>
-                    <a:lstStyle/>
-                    <a:p>
-                      <a:pPr algn="ctr" fontAlgn="b">
-                        <a:buNone/>
-                      </a:pPr>
-                      <a:endParaRPr lang="en-FR" sz="1100" b="0" i="0" u="none" strike="noStrike" dirty="0">
-                        <a:effectLst/>
-                        <a:latin typeface="Carlito"/>
-                      </a:endParaRPr>
-                    </a:p>
-                  </a:txBody>
-                  <a:tcPr marL="9525" marR="9525" marT="9525" marB="0" anchor="b"/>
-                </a:tc>
-                <a:extLst>
-                  <a:ext uri="{0D108BD9-81ED-4DB2-BD59-A6C34878D82A}">
-                    <a16:rowId xmlns:a16="http://schemas.microsoft.com/office/drawing/2014/main" val="2726320237"/>
-                  </a:ext>
-                </a:extLst>
-              </a:tr>
-              <a:tr h="118104">
-                <a:tc>
-                  <a:txBody>
-                    <a:bodyPr/>
-                    <a:lstStyle/>
-                    <a:p>
-                      <a:pPr marL="0" marR="0" lvl="0" indent="0" algn="ctr" defTabSz="914400" rtl="0" eaLnBrk="1" fontAlgn="b" latinLnBrk="0" hangingPunct="1">
-                        <a:lnSpc>
-                          <a:spcPct val="100000"/>
-                        </a:lnSpc>
-                        <a:spcBef>
-                          <a:spcPts val="0"/>
-                        </a:spcBef>
-                        <a:spcAft>
-                          <a:spcPts val="0"/>
-                        </a:spcAft>
-                        <a:buClrTx/>
-                        <a:buSzTx/>
-                        <a:buFontTx/>
-                        <a:buNone/>
-                        <a:tabLst/>
-                        <a:defRPr/>
-                      </a:pPr>
-                      <a:r>
-                        <a:rPr kumimoji="0" lang="en-FR" sz="1100" b="0" i="0" u="none" strike="noStrike" kern="1200" cap="none" spc="0" normalizeH="0" baseline="0" noProof="0">
-                          <a:ln>
-                            <a:noFill/>
-                          </a:ln>
-                          <a:solidFill>
-                            <a:prstClr val="black"/>
-                          </a:solidFill>
-                          <a:effectLst/>
-                          <a:uLnTx/>
-                          <a:uFillTx/>
-                          <a:latin typeface="Aptos" panose="02110004020202020204"/>
-                          <a:ea typeface="+mn-ea"/>
-                          <a:cs typeface="+mn-cs"/>
-                        </a:rPr>
-                        <a:t>Oncology</a:t>
-                      </a:r>
-                      <a:endParaRPr kumimoji="0" lang="en-FR" sz="1100" b="0" i="0" u="none" strike="noStrike" kern="1200" cap="none" spc="0" normalizeH="0" baseline="0" noProof="0" dirty="0">
-                        <a:ln>
-                          <a:noFill/>
-                        </a:ln>
-                        <a:solidFill>
-                          <a:prstClr val="black"/>
-                        </a:solidFill>
-                        <a:effectLst/>
-                        <a:uLnTx/>
-                        <a:uFillTx/>
-                        <a:latin typeface="Carlito"/>
-                        <a:ea typeface="+mn-ea"/>
-                        <a:cs typeface="+mn-cs"/>
-                      </a:endParaRPr>
-                    </a:p>
-                  </a:txBody>
-                  <a:tcPr marL="9525" marR="9525" marT="9525" marB="0" anchor="b"/>
-                </a:tc>
-                <a:tc>
-                  <a:txBody>
-                    <a:bodyPr/>
-                    <a:lstStyle/>
-                    <a:p>
-                      <a:pPr algn="ctr" fontAlgn="b">
-                        <a:buNone/>
-                      </a:pPr>
-                      <a:r>
-                        <a:rPr lang="en-FR" sz="1000" b="0" u="none" strike="noStrike" dirty="0">
-                          <a:solidFill>
-                            <a:srgbClr val="000000"/>
-                          </a:solidFill>
-                          <a:effectLst/>
-                          <a:latin typeface="Arial" panose="020B0604020202020204" pitchFamily="34" charset="0"/>
-                          <a:cs typeface="Arial" panose="020B0604020202020204" pitchFamily="34" charset="0"/>
-                        </a:rPr>
-                        <a:t>Decapeptyl</a:t>
-                      </a:r>
-                      <a:endParaRPr lang="en-FR" sz="1000" b="0" i="0" u="none" strike="noStrike" dirty="0">
-                        <a:solidFill>
-                          <a:srgbClr val="000000"/>
-                        </a:solidFill>
-                        <a:effectLst/>
-                        <a:latin typeface="Arial" panose="020B0604020202020204" pitchFamily="34" charset="0"/>
-                        <a:cs typeface="Arial" panose="020B0604020202020204" pitchFamily="34" charset="0"/>
-                      </a:endParaRPr>
-                    </a:p>
-                  </a:txBody>
-                  <a:tcPr marL="9525" marR="9525" marT="9525" marB="0" anchor="ctr"/>
-                </a:tc>
-                <a:tc>
-                  <a:txBody>
-                    <a:bodyPr/>
-                    <a:lstStyle/>
-                    <a:p>
-                      <a:pPr algn="ctr" fontAlgn="b">
-                        <a:buNone/>
-                      </a:pPr>
-                      <a:endParaRPr lang="en-FR" sz="1100" b="0" i="0" u="none" strike="noStrike" dirty="0">
-                        <a:effectLst/>
-                        <a:latin typeface="Carlito"/>
-                      </a:endParaRPr>
-                    </a:p>
-                  </a:txBody>
-                  <a:tcPr marL="9525" marR="9525" marT="9525" marB="0" anchor="b"/>
-                </a:tc>
-                <a:extLst>
-                  <a:ext uri="{0D108BD9-81ED-4DB2-BD59-A6C34878D82A}">
-                    <a16:rowId xmlns:a16="http://schemas.microsoft.com/office/drawing/2014/main" val="591110887"/>
-                  </a:ext>
-                </a:extLst>
-              </a:tr>
-              <a:tr h="118104">
-                <a:tc>
-                  <a:txBody>
-                    <a:bodyPr/>
-                    <a:lstStyle/>
-                    <a:p>
-                      <a:pPr marL="0" marR="0" lvl="0" indent="0" algn="ctr" defTabSz="914400" rtl="0" eaLnBrk="1" fontAlgn="b" latinLnBrk="0" hangingPunct="1">
-                        <a:lnSpc>
-                          <a:spcPct val="100000"/>
-                        </a:lnSpc>
-                        <a:spcBef>
-                          <a:spcPts val="0"/>
-                        </a:spcBef>
-                        <a:spcAft>
-                          <a:spcPts val="0"/>
-                        </a:spcAft>
-                        <a:buClrTx/>
-                        <a:buSzTx/>
-                        <a:buFontTx/>
-                        <a:buNone/>
-                        <a:tabLst/>
-                        <a:defRPr/>
-                      </a:pPr>
-                      <a:r>
-                        <a:rPr kumimoji="0" lang="en-FR" sz="1100" b="0" i="0" u="none" strike="noStrike" kern="1200" cap="none" spc="0" normalizeH="0" baseline="0" noProof="0">
-                          <a:ln>
-                            <a:noFill/>
-                          </a:ln>
-                          <a:solidFill>
-                            <a:prstClr val="black"/>
-                          </a:solidFill>
-                          <a:effectLst/>
-                          <a:uLnTx/>
-                          <a:uFillTx/>
-                          <a:latin typeface="Aptos" panose="02110004020202020204"/>
-                          <a:ea typeface="+mn-ea"/>
-                          <a:cs typeface="+mn-cs"/>
-                        </a:rPr>
-                        <a:t>Oncology</a:t>
-                      </a:r>
-                      <a:endParaRPr kumimoji="0" lang="en-FR" sz="1100" b="0" i="0" u="none" strike="noStrike" kern="1200" cap="none" spc="0" normalizeH="0" baseline="0" noProof="0" dirty="0">
-                        <a:ln>
-                          <a:noFill/>
-                        </a:ln>
-                        <a:solidFill>
-                          <a:prstClr val="black"/>
-                        </a:solidFill>
-                        <a:effectLst/>
-                        <a:uLnTx/>
-                        <a:uFillTx/>
-                        <a:latin typeface="Carlito"/>
-                        <a:ea typeface="+mn-ea"/>
-                        <a:cs typeface="+mn-cs"/>
-                      </a:endParaRPr>
-                    </a:p>
-                  </a:txBody>
-                  <a:tcPr marL="9525" marR="9525" marT="9525" marB="0" anchor="b"/>
-                </a:tc>
-                <a:tc>
-                  <a:txBody>
-                    <a:bodyPr/>
-                    <a:lstStyle/>
-                    <a:p>
-                      <a:pPr algn="ctr" fontAlgn="b">
-                        <a:buNone/>
-                      </a:pPr>
-                      <a:r>
-                        <a:rPr lang="en-FR" sz="1000" b="0" u="none" strike="noStrike" dirty="0">
-                          <a:solidFill>
-                            <a:srgbClr val="000000"/>
-                          </a:solidFill>
-                          <a:effectLst/>
-                          <a:latin typeface="Arial" panose="020B0604020202020204" pitchFamily="34" charset="0"/>
-                          <a:cs typeface="Arial" panose="020B0604020202020204" pitchFamily="34" charset="0"/>
-                        </a:rPr>
-                        <a:t>Onivyde</a:t>
-                      </a:r>
-                      <a:endParaRPr lang="en-FR" sz="1000" b="0" i="0" u="none" strike="noStrike" dirty="0">
-                        <a:solidFill>
-                          <a:srgbClr val="000000"/>
-                        </a:solidFill>
-                        <a:effectLst/>
-                        <a:latin typeface="Arial" panose="020B0604020202020204" pitchFamily="34" charset="0"/>
-                        <a:cs typeface="Arial" panose="020B0604020202020204" pitchFamily="34" charset="0"/>
-                      </a:endParaRPr>
-                    </a:p>
-                  </a:txBody>
-                  <a:tcPr marL="9525" marR="9525" marT="9525" marB="0" anchor="ctr"/>
-                </a:tc>
-                <a:tc>
-                  <a:txBody>
-                    <a:bodyPr/>
-                    <a:lstStyle/>
-                    <a:p>
-                      <a:pPr algn="ctr" fontAlgn="b">
-                        <a:buNone/>
-                      </a:pPr>
-                      <a:endParaRPr lang="en-FR" sz="1100" b="0" i="0" u="none" strike="noStrike" dirty="0">
-                        <a:effectLst/>
-                        <a:latin typeface="Carlito"/>
-                      </a:endParaRPr>
-                    </a:p>
-                  </a:txBody>
-                  <a:tcPr marL="9525" marR="9525" marT="9525" marB="0" anchor="b"/>
-                </a:tc>
-                <a:extLst>
-                  <a:ext uri="{0D108BD9-81ED-4DB2-BD59-A6C34878D82A}">
-                    <a16:rowId xmlns:a16="http://schemas.microsoft.com/office/drawing/2014/main" val="3939620745"/>
-                  </a:ext>
-                </a:extLst>
-              </a:tr>
-              <a:tr h="118104">
-                <a:tc>
-                  <a:txBody>
-                    <a:bodyPr/>
-                    <a:lstStyle/>
-                    <a:p>
-                      <a:pPr marL="0" marR="0" lvl="0" indent="0" algn="ctr" defTabSz="914400" rtl="0" eaLnBrk="1" fontAlgn="b" latinLnBrk="0" hangingPunct="1">
-                        <a:lnSpc>
-                          <a:spcPct val="100000"/>
-                        </a:lnSpc>
-                        <a:spcBef>
-                          <a:spcPts val="0"/>
-                        </a:spcBef>
-                        <a:spcAft>
-                          <a:spcPts val="0"/>
-                        </a:spcAft>
-                        <a:buClrTx/>
-                        <a:buSzTx/>
-                        <a:buFontTx/>
-                        <a:buNone/>
-                        <a:tabLst/>
-                        <a:defRPr/>
-                      </a:pPr>
-                      <a:r>
-                        <a:rPr kumimoji="0" lang="en-FR" sz="1100" b="0" i="0" u="none" strike="noStrike" kern="1200" cap="none" spc="0" normalizeH="0" baseline="0" noProof="0" dirty="0">
-                          <a:ln>
-                            <a:noFill/>
-                          </a:ln>
-                          <a:solidFill>
-                            <a:prstClr val="black"/>
-                          </a:solidFill>
-                          <a:effectLst/>
-                          <a:uLnTx/>
-                          <a:uFillTx/>
-                          <a:latin typeface="Aptos" panose="02110004020202020204"/>
-                          <a:ea typeface="+mn-ea"/>
-                          <a:cs typeface="+mn-cs"/>
-                        </a:rPr>
-                        <a:t>Oncology</a:t>
-                      </a:r>
-                      <a:endParaRPr kumimoji="0" lang="en-FR" sz="1100" b="0" i="0" u="none" strike="noStrike" kern="1200" cap="none" spc="0" normalizeH="0" baseline="0" noProof="0" dirty="0">
-                        <a:ln>
-                          <a:noFill/>
-                        </a:ln>
-                        <a:solidFill>
-                          <a:prstClr val="black"/>
-                        </a:solidFill>
-                        <a:effectLst/>
-                        <a:uLnTx/>
-                        <a:uFillTx/>
-                        <a:latin typeface="Carlito"/>
-                        <a:ea typeface="+mn-ea"/>
-                        <a:cs typeface="+mn-cs"/>
-                      </a:endParaRPr>
-                    </a:p>
-                  </a:txBody>
-                  <a:tcPr marL="9525" marR="9525" marT="9525" marB="0" anchor="b"/>
-                </a:tc>
-                <a:tc>
-                  <a:txBody>
-                    <a:bodyPr/>
-                    <a:lstStyle/>
-                    <a:p>
-                      <a:pPr marL="0" marR="0" lvl="0" indent="0" algn="ctr" defTabSz="914400" rtl="0" eaLnBrk="1" fontAlgn="b" latinLnBrk="0" hangingPunct="1">
-                        <a:lnSpc>
-                          <a:spcPct val="100000"/>
-                        </a:lnSpc>
-                        <a:spcBef>
-                          <a:spcPts val="0"/>
-                        </a:spcBef>
-                        <a:spcAft>
-                          <a:spcPts val="0"/>
-                        </a:spcAft>
-                        <a:buClrTx/>
-                        <a:buSzTx/>
-                        <a:buFontTx/>
-                        <a:buNone/>
-                        <a:tabLst/>
-                        <a:defRPr/>
-                      </a:pPr>
-                      <a:r>
-                        <a:rPr lang="en-FR" sz="1100" b="0" u="none" strike="noStrike" dirty="0">
-                          <a:effectLst/>
-                        </a:rPr>
-                        <a:t>Ojemda</a:t>
-                      </a:r>
-                      <a:endParaRPr lang="en-FR" sz="1100" b="0" i="0" u="none" strike="noStrike" dirty="0">
-                        <a:effectLst/>
-                        <a:latin typeface="Carlito"/>
-                      </a:endParaRPr>
-                    </a:p>
-                  </a:txBody>
-                  <a:tcPr marL="9525" marR="9525" marT="9525" marB="0" anchor="b"/>
-                </a:tc>
-                <a:tc>
-                  <a:txBody>
-                    <a:bodyPr/>
-                    <a:lstStyle/>
-                    <a:p>
-                      <a:pPr algn="ctr" fontAlgn="b">
-                        <a:buNone/>
-                      </a:pPr>
-                      <a:r>
-                        <a:rPr lang="en-GB" sz="1100" b="0" u="none" strike="noStrike" dirty="0">
-                          <a:effectLst/>
-                        </a:rPr>
-                        <a:t>RAF inhibitor targeting BRAF</a:t>
-                      </a:r>
-                      <a:endParaRPr lang="en-FR" sz="1100" b="0" i="0" u="none" strike="noStrike" dirty="0">
-                        <a:effectLst/>
-                        <a:latin typeface="Carlito"/>
-                      </a:endParaRPr>
-                    </a:p>
-                  </a:txBody>
-                  <a:tcPr marL="9525" marR="9525" marT="9525" marB="0" anchor="b"/>
-                </a:tc>
-                <a:extLst>
-                  <a:ext uri="{0D108BD9-81ED-4DB2-BD59-A6C34878D82A}">
-                    <a16:rowId xmlns:a16="http://schemas.microsoft.com/office/drawing/2014/main" val="1210521652"/>
-                  </a:ext>
-                </a:extLst>
-              </a:tr>
-              <a:tr h="118104">
-                <a:tc>
-                  <a:txBody>
-                    <a:bodyPr/>
-                    <a:lstStyle/>
-                    <a:p>
-                      <a:pPr algn="ctr" fontAlgn="b">
-                        <a:buNone/>
-                      </a:pPr>
-                      <a:r>
-                        <a:rPr lang="en-FR" sz="1100" b="0" u="none" strike="noStrike" dirty="0">
-                          <a:effectLst/>
-                        </a:rPr>
-                        <a:t>Oncology</a:t>
-                      </a:r>
-                      <a:endParaRPr lang="en-FR" sz="1100" b="0" i="0" u="none" strike="noStrike" dirty="0">
-                        <a:effectLst/>
-                        <a:latin typeface="Carlito"/>
-                      </a:endParaRPr>
-                    </a:p>
-                  </a:txBody>
-                  <a:tcPr marL="9525" marR="9525" marT="9525" marB="0" anchor="b"/>
-                </a:tc>
-                <a:tc>
-                  <a:txBody>
-                    <a:bodyPr/>
-                    <a:lstStyle/>
-                    <a:p>
-                      <a:pPr marL="0" marR="0" lvl="0" indent="0" algn="ctr" defTabSz="914400" rtl="0" eaLnBrk="1" fontAlgn="b" latinLnBrk="0" hangingPunct="1">
-                        <a:lnSpc>
-                          <a:spcPct val="100000"/>
-                        </a:lnSpc>
-                        <a:spcBef>
-                          <a:spcPts val="0"/>
-                        </a:spcBef>
-                        <a:spcAft>
-                          <a:spcPts val="0"/>
-                        </a:spcAft>
-                        <a:buClrTx/>
-                        <a:buSzTx/>
-                        <a:buFontTx/>
-                        <a:buNone/>
-                        <a:tabLst/>
-                        <a:defRPr/>
-                      </a:pPr>
-                      <a:r>
-                        <a:rPr lang="en-FR" sz="1100" b="0" u="none" strike="noStrike" dirty="0">
-                          <a:effectLst/>
-                        </a:rPr>
-                        <a:t>IPN60340 / ICT01</a:t>
-                      </a:r>
-                      <a:r>
-                        <a:rPr lang="en-FR" sz="1100" b="0" i="0" u="none" strike="noStrike" dirty="0">
-                          <a:effectLst/>
-                          <a:latin typeface="Carlito"/>
-                        </a:rPr>
-                        <a:t>, </a:t>
-                      </a:r>
-                      <a:r>
-                        <a:rPr lang="en-FR" sz="1100" b="0" u="none" strike="noStrike" dirty="0">
-                          <a:effectLst/>
-                        </a:rPr>
-                        <a:t>IPN01203</a:t>
-                      </a:r>
-                      <a:endParaRPr lang="en-FR" sz="1100" b="0" i="0" u="none" strike="noStrike" dirty="0">
-                        <a:effectLst/>
-                        <a:latin typeface="Carlito"/>
-                      </a:endParaRPr>
-                    </a:p>
-                  </a:txBody>
-                  <a:tcPr marL="9525" marR="9525" marT="9525" marB="0" anchor="b"/>
-                </a:tc>
-                <a:tc>
-                  <a:txBody>
-                    <a:bodyPr/>
-                    <a:lstStyle/>
-                    <a:p>
-                      <a:pPr algn="ctr" fontAlgn="b">
-                        <a:buNone/>
-                      </a:pPr>
-                      <a:r>
-                        <a:rPr lang="en-GB" sz="1100" b="0" u="none" strike="noStrike" dirty="0">
-                          <a:effectLst/>
-                        </a:rPr>
-                        <a:t>T-cell activator</a:t>
-                      </a:r>
-                      <a:endParaRPr lang="en-FR" sz="1100" b="0" i="0" u="none" strike="noStrike" dirty="0">
-                        <a:effectLst/>
-                        <a:latin typeface="Carlito"/>
-                      </a:endParaRPr>
-                    </a:p>
-                  </a:txBody>
-                  <a:tcPr marL="9525" marR="9525" marT="9525" marB="0" anchor="b"/>
-                </a:tc>
-                <a:extLst>
-                  <a:ext uri="{0D108BD9-81ED-4DB2-BD59-A6C34878D82A}">
-                    <a16:rowId xmlns:a16="http://schemas.microsoft.com/office/drawing/2014/main" val="1864132227"/>
-                  </a:ext>
-                </a:extLst>
-              </a:tr>
-              <a:tr h="118104">
-                <a:tc>
-                  <a:txBody>
-                    <a:bodyPr/>
-                    <a:lstStyle/>
-                    <a:p>
-                      <a:pPr algn="ctr" fontAlgn="b">
-                        <a:buNone/>
-                      </a:pPr>
-                      <a:r>
-                        <a:rPr lang="en-FR" sz="1100" b="0" i="0" u="none" strike="noStrike" dirty="0">
-                          <a:effectLst/>
-                          <a:latin typeface="Carlito"/>
-                        </a:rPr>
-                        <a:t>Rare Diseases</a:t>
-                      </a:r>
-                    </a:p>
-                  </a:txBody>
-                  <a:tcPr marL="9525" marR="9525" marT="9525" marB="0" anchor="b"/>
-                </a:tc>
-                <a:tc>
-                  <a:txBody>
-                    <a:bodyPr/>
-                    <a:lstStyle/>
-                    <a:p>
-                      <a:pPr algn="ctr" fontAlgn="b">
-                        <a:buNone/>
-                      </a:pPr>
-                      <a:r>
-                        <a:rPr lang="en-FR" sz="1100" b="0" u="none" strike="noStrike" dirty="0">
-                          <a:effectLst/>
-                        </a:rPr>
-                        <a:t>Iqirvo, Elafibranor</a:t>
-                      </a:r>
-                      <a:endParaRPr lang="en-FR" sz="1100" b="0" i="0" u="none" strike="noStrike" dirty="0">
-                        <a:effectLst/>
-                        <a:latin typeface="Carlito"/>
-                      </a:endParaRPr>
-                    </a:p>
-                  </a:txBody>
-                  <a:tcPr marL="9525" marR="9525" marT="9525" marB="0" anchor="b"/>
-                </a:tc>
-                <a:tc>
-                  <a:txBody>
-                    <a:bodyPr/>
-                    <a:lstStyle/>
-                    <a:p>
-                      <a:pPr algn="ctr" fontAlgn="b">
-                        <a:buNone/>
-                      </a:pPr>
-                      <a:r>
-                        <a:rPr lang="en-GB" sz="1100" b="0" u="none" strike="noStrike" dirty="0">
-                          <a:effectLst/>
-                        </a:rPr>
-                        <a:t>PPAR </a:t>
-                      </a:r>
-                      <a:r>
-                        <a:rPr lang="el-GR" sz="1100" b="0" u="none" strike="noStrike" dirty="0">
-                          <a:effectLst/>
-                        </a:rPr>
-                        <a:t>α/δ </a:t>
-                      </a:r>
-                      <a:r>
-                        <a:rPr lang="en-GB" sz="1100" b="0" u="none" strike="noStrike" dirty="0">
-                          <a:effectLst/>
-                        </a:rPr>
-                        <a:t>agonist</a:t>
-                      </a:r>
-                      <a:endParaRPr lang="en-FR" sz="1100" b="0" i="0" u="none" strike="noStrike" dirty="0">
-                        <a:effectLst/>
-                        <a:latin typeface="Carlito"/>
-                      </a:endParaRPr>
-                    </a:p>
-                  </a:txBody>
-                  <a:tcPr marL="9525" marR="9525" marT="9525" marB="0" anchor="b"/>
-                </a:tc>
-                <a:extLst>
-                  <a:ext uri="{0D108BD9-81ED-4DB2-BD59-A6C34878D82A}">
-                    <a16:rowId xmlns:a16="http://schemas.microsoft.com/office/drawing/2014/main" val="1800218135"/>
-                  </a:ext>
-                </a:extLst>
-              </a:tr>
-              <a:tr h="118104">
-                <a:tc>
-                  <a:txBody>
-                    <a:bodyPr/>
-                    <a:lstStyle/>
-                    <a:p>
-                      <a:pPr algn="ctr" fontAlgn="b">
-                        <a:buNone/>
-                      </a:pPr>
-                      <a:r>
-                        <a:rPr lang="en-FR" sz="1100" b="0" u="none" strike="noStrike" dirty="0">
-                          <a:effectLst/>
-                        </a:rPr>
-                        <a:t>Neuroscience</a:t>
-                      </a:r>
-                      <a:endParaRPr lang="en-FR" sz="1100" b="0" i="0" u="none" strike="noStrike" dirty="0">
-                        <a:effectLst/>
-                        <a:latin typeface="Carlito"/>
-                      </a:endParaRPr>
-                    </a:p>
-                  </a:txBody>
-                  <a:tcPr marL="9525" marR="9525" marT="9525" marB="0" anchor="b"/>
-                </a:tc>
-                <a:tc>
-                  <a:txBody>
-                    <a:bodyPr/>
-                    <a:lstStyle/>
-                    <a:p>
-                      <a:pPr marL="0" marR="0" lvl="0" indent="0" algn="ctr" defTabSz="914400" rtl="0" eaLnBrk="1" fontAlgn="b" latinLnBrk="0" hangingPunct="1">
-                        <a:lnSpc>
-                          <a:spcPct val="100000"/>
-                        </a:lnSpc>
-                        <a:spcBef>
-                          <a:spcPts val="0"/>
-                        </a:spcBef>
-                        <a:spcAft>
-                          <a:spcPts val="0"/>
-                        </a:spcAft>
-                        <a:buClrTx/>
-                        <a:buSzTx/>
-                        <a:buFontTx/>
-                        <a:buNone/>
-                        <a:tabLst/>
-                        <a:defRPr/>
-                      </a:pPr>
-                      <a:r>
-                        <a:rPr lang="en-FR" sz="1100" b="0" u="none" strike="noStrike" dirty="0">
-                          <a:effectLst/>
-                        </a:rPr>
-                        <a:t>Corabotase</a:t>
-                      </a:r>
-                      <a:endParaRPr lang="en-FR" sz="1100" b="0" i="0" u="none" strike="noStrike" dirty="0">
-                        <a:effectLst/>
-                        <a:latin typeface="Carlito"/>
-                      </a:endParaRPr>
-                    </a:p>
-                  </a:txBody>
-                  <a:tcPr marL="9525" marR="9525" marT="9525" marB="0" anchor="b"/>
-                </a:tc>
-                <a:tc>
-                  <a:txBody>
-                    <a:bodyPr/>
-                    <a:lstStyle/>
-                    <a:p>
-                      <a:pPr algn="ctr" fontAlgn="b">
-                        <a:buNone/>
-                      </a:pPr>
-                      <a:endParaRPr lang="en-FR" sz="1100" b="0" i="0" u="none" strike="noStrike" dirty="0">
-                        <a:effectLst/>
-                        <a:latin typeface="Carlito"/>
-                      </a:endParaRPr>
-                    </a:p>
-                  </a:txBody>
-                  <a:tcPr marL="9525" marR="9525" marT="9525" marB="0" anchor="b"/>
-                </a:tc>
-                <a:extLst>
-                  <a:ext uri="{0D108BD9-81ED-4DB2-BD59-A6C34878D82A}">
-                    <a16:rowId xmlns:a16="http://schemas.microsoft.com/office/drawing/2014/main" val="19971142"/>
-                  </a:ext>
-                </a:extLst>
-              </a:tr>
-            </a:tbl>
-          </a:graphicData>
-        </a:graphic>
-      </p:graphicFrame>
-      <p:sp>
-        <p:nvSpPr>
-          <p:cNvPr id="15" name="Rectangle 14">
-            <a:extLst>
-              <a:ext uri="{FF2B5EF4-FFF2-40B4-BE49-F238E27FC236}">
-                <a16:creationId xmlns:a16="http://schemas.microsoft.com/office/drawing/2014/main" id="{B37309D6-F235-4153-66C5-EABAD384377D}"/>
+                <a16:creationId xmlns:a16="http://schemas.microsoft.com/office/drawing/2014/main" id="{AE78747F-ED8F-6803-3399-5D848F893357}"/>
               </a:ext>
             </a:extLst>
           </p:cNvPr>
@@ -10480,7 +9162,7 @@
         </p:nvSpPr>
         <p:spPr>
           <a:xfrm>
-            <a:off x="526950" y="3711858"/>
+            <a:off x="4697616" y="2380916"/>
             <a:ext cx="2900922" cy="45719"/>
           </a:xfrm>
           <a:prstGeom prst="rect">
@@ -10520,10 +9202,10 @@
       </p:sp>
       <p:sp>
         <p:nvSpPr>
-          <p:cNvPr id="16" name="TextBox 15">
+          <p:cNvPr id="18" name="TextBox 17">
             <a:extLst>
               <a:ext uri="{FF2B5EF4-FFF2-40B4-BE49-F238E27FC236}">
-                <a16:creationId xmlns:a16="http://schemas.microsoft.com/office/drawing/2014/main" id="{D6943AD7-58A9-9ECC-E9B3-78E67C6D31AD}"/>
+                <a16:creationId xmlns:a16="http://schemas.microsoft.com/office/drawing/2014/main" id="{3FC1522C-6AB8-3A42-FBC1-32A1AF43BE03}"/>
               </a:ext>
             </a:extLst>
           </p:cNvPr>
@@ -10532,8 +9214,8 @@
         </p:nvSpPr>
         <p:spPr>
           <a:xfrm>
-            <a:off x="451104" y="3365385"/>
-            <a:ext cx="1183978" cy="369332"/>
+            <a:off x="4621770" y="2034443"/>
+            <a:ext cx="1963807" cy="369332"/>
           </a:xfrm>
           <a:prstGeom prst="rect">
             <a:avLst/>
@@ -10552,17 +9234,70 @@
                   <a:srgbClr val="163B5A"/>
                 </a:solidFill>
               </a:rPr>
-              <a:t>Oncology</a:t>
+              <a:t>PPAR </a:t>
+            </a:r>
+            <a:r>
+              <a:rPr lang="el-GR" b="1" dirty="0">
+                <a:solidFill>
+                  <a:srgbClr val="163B5A"/>
+                </a:solidFill>
+              </a:rPr>
+              <a:t>α/δ </a:t>
+            </a:r>
+            <a:r>
+              <a:rPr lang="en-AU" b="1" dirty="0">
+                <a:solidFill>
+                  <a:srgbClr val="163B5A"/>
+                </a:solidFill>
+              </a:rPr>
+              <a:t>agonist</a:t>
             </a:r>
           </a:p>
         </p:txBody>
       </p:sp>
       <p:sp>
         <p:nvSpPr>
-          <p:cNvPr id="17" name="Rectangle 16">
+          <p:cNvPr id="20" name="TextBox 19">
             <a:extLst>
               <a:ext uri="{FF2B5EF4-FFF2-40B4-BE49-F238E27FC236}">
-                <a16:creationId xmlns:a16="http://schemas.microsoft.com/office/drawing/2014/main" id="{AE78747F-ED8F-6803-3399-5D848F893357}"/>
+                <a16:creationId xmlns:a16="http://schemas.microsoft.com/office/drawing/2014/main" id="{AC20A729-A476-3ADB-A2A7-82EFA36482DF}"/>
+              </a:ext>
+            </a:extLst>
+          </p:cNvPr>
+          <p:cNvSpPr txBox="1"/>
+          <p:nvPr/>
+        </p:nvSpPr>
+        <p:spPr>
+          <a:xfrm>
+            <a:off x="451103" y="1154740"/>
+            <a:ext cx="11289791" cy="646331"/>
+          </a:xfrm>
+          <a:prstGeom prst="rect">
+            <a:avLst/>
+          </a:prstGeom>
+          <a:noFill/>
+        </p:spPr>
+        <p:txBody>
+          <a:bodyPr wrap="square">
+            <a:spAutoFit/>
+          </a:bodyPr>
+          <a:lstStyle/>
+          <a:p>
+            <a:pPr algn="ctr"/>
+            <a:r>
+              <a:rPr lang="en-FR" dirty="0"/>
+              <a:t>Focus rationale: Ipsen revenue concentrates in 3 franchises (Onco 69%, Neuro 20%, Rare disease 11%). We analyze the 2 markets defining its strategic trajectory: [marché 1] and [marché 2]</a:t>
+            </a:r>
+            <a:endParaRPr lang="en-AU" dirty="0"/>
+          </a:p>
+        </p:txBody>
+      </p:sp>
+      <p:sp>
+        <p:nvSpPr>
+          <p:cNvPr id="21" name="Rectangle 20">
+            <a:extLst>
+              <a:ext uri="{FF2B5EF4-FFF2-40B4-BE49-F238E27FC236}">
+                <a16:creationId xmlns:a16="http://schemas.microsoft.com/office/drawing/2014/main" id="{E6F32A66-789B-0E8C-C5F8-B8D0E3CDAA2F}"/>
               </a:ext>
             </a:extLst>
           </p:cNvPr>
@@ -10571,7 +9306,7 @@
         </p:nvSpPr>
         <p:spPr>
           <a:xfrm>
-            <a:off x="4697616" y="3711858"/>
+            <a:off x="8839972" y="2380915"/>
             <a:ext cx="2900922" cy="45719"/>
           </a:xfrm>
           <a:prstGeom prst="rect">
@@ -10611,10 +9346,10 @@
       </p:sp>
       <p:sp>
         <p:nvSpPr>
-          <p:cNvPr id="18" name="TextBox 17">
+          <p:cNvPr id="22" name="TextBox 21">
             <a:extLst>
               <a:ext uri="{FF2B5EF4-FFF2-40B4-BE49-F238E27FC236}">
-                <a16:creationId xmlns:a16="http://schemas.microsoft.com/office/drawing/2014/main" id="{3FC1522C-6AB8-3A42-FBC1-32A1AF43BE03}"/>
+                <a16:creationId xmlns:a16="http://schemas.microsoft.com/office/drawing/2014/main" id="{0EA7F4BC-4214-0A86-8100-D05D7CEA4315}"/>
               </a:ext>
             </a:extLst>
           </p:cNvPr>
@@ -10623,7 +9358,7 @@
         </p:nvSpPr>
         <p:spPr>
           <a:xfrm>
-            <a:off x="4621770" y="3365385"/>
+            <a:off x="8764126" y="2034442"/>
             <a:ext cx="1963807" cy="369332"/>
           </a:xfrm>
           <a:prstGeom prst="rect">
@@ -10913,13 +9648,18 @@
           <a:lstStyle/>
           <a:p>
             <a:r>
-              <a:rPr lang="en-AU" sz="1400" dirty="0">
-                <a:solidFill>
-                  <a:srgbClr val="163B5A"/>
-                </a:solidFill>
-              </a:rPr>
-              <a:t>XXXX</a:t>
-            </a:r>
+              <a:rPr lang="en-US" sz="1400" dirty="0"/>
+              <a:t>Ipsen target a very diversified specialty-care portfolio to secure revenue and decrease dependency on few oncology </a:t>
+            </a:r>
+            <a:r>
+              <a:rPr lang="en-US" sz="1400" dirty="0" err="1"/>
+              <a:t>produtcs</a:t>
+            </a:r>
+            <a:endParaRPr lang="en-AU" sz="1400" dirty="0">
+              <a:solidFill>
+                <a:srgbClr val="163B5A"/>
+              </a:solidFill>
+            </a:endParaRPr>
           </a:p>
         </p:txBody>
       </p:sp>
@@ -13433,7 +12173,7 @@
         </p:nvSpPr>
         <p:spPr>
           <a:xfrm>
-            <a:off x="7649776" y="4821943"/>
+            <a:off x="7368561" y="5024970"/>
             <a:ext cx="2900922" cy="45719"/>
           </a:xfrm>
           <a:prstGeom prst="rect">
@@ -13485,7 +12225,7 @@
         </p:nvSpPr>
         <p:spPr>
           <a:xfrm>
-            <a:off x="7573930" y="4475470"/>
+            <a:off x="7292715" y="4678497"/>
             <a:ext cx="2329292" cy="369332"/>
           </a:xfrm>
           <a:prstGeom prst="rect">
@@ -13525,7 +12265,7 @@
         <p:spPr>
           <a:xfrm>
             <a:off x="451104" y="5167338"/>
-            <a:ext cx="6604001" cy="1015663"/>
+            <a:ext cx="6604001" cy="1569660"/>
           </a:xfrm>
           <a:prstGeom prst="rect">
             <a:avLst/>
@@ -13543,26 +12283,9 @@
               <a:buChar char="•"/>
             </a:pPr>
             <a:r>
-              <a:rPr lang="en-US" sz="1200" b="1" dirty="0" err="1"/>
-              <a:t>Portefeuil</a:t>
-            </a:r>
-            <a:r>
-              <a:rPr lang="en-US" sz="1200" b="1" dirty="0"/>
-              <a:t> </a:t>
-            </a:r>
-            <a:r>
-              <a:rPr lang="en-US" sz="1200" b="1" dirty="0" err="1"/>
-              <a:t>devient</a:t>
-            </a:r>
-            <a:r>
-              <a:rPr lang="en-US" sz="1200" b="1" dirty="0"/>
-              <a:t> très </a:t>
-            </a:r>
-            <a:r>
-              <a:rPr lang="en-US" sz="1200" b="1" dirty="0" err="1"/>
-              <a:t>diversifié</a:t>
-            </a:r>
-            <a:endParaRPr lang="en-US" sz="1200" b="1" dirty="0"/>
+              <a:rPr lang="en-US" sz="1200" dirty="0"/>
+              <a:t>Diversified specialty-care portfolio, with Oncology as the revenue backbone</a:t>
+            </a:r>
           </a:p>
           <a:p>
             <a:pPr marL="285750" indent="-285750">
@@ -13570,13 +12293,38 @@
               <a:buChar char="•"/>
             </a:pPr>
             <a:r>
-              <a:rPr lang="en-US" sz="1200" b="1" dirty="0"/>
-              <a:t>Clear post-2020 external-innovation reset: </a:t>
-            </a:r>
-            <a:r>
               <a:rPr lang="en-US" sz="1200" dirty="0"/>
-              <a:t>30 best-/first-in-class programs brought into the pipeline since 2020.</a:t>
-            </a:r>
+              <a:t>Oncology driven by mature but resilient franchises: </a:t>
+            </a:r>
+            <a:r>
+              <a:rPr lang="en-US" sz="1200" dirty="0" err="1"/>
+              <a:t>Somatuline</a:t>
+            </a:r>
+            <a:r>
+              <a:rPr lang="en-US" sz="1200" dirty="0"/>
+              <a:t>, </a:t>
+            </a:r>
+            <a:r>
+              <a:rPr lang="en-US" sz="1200" dirty="0" err="1"/>
+              <a:t>Cabometyx</a:t>
+            </a:r>
+            <a:r>
+              <a:rPr lang="en-US" sz="1200" dirty="0"/>
+              <a:t>, </a:t>
+            </a:r>
+            <a:r>
+              <a:rPr lang="en-US" sz="1200" dirty="0" err="1"/>
+              <a:t>Decapeptyl</a:t>
+            </a:r>
+            <a:r>
+              <a:rPr lang="en-US" sz="1200" dirty="0"/>
+              <a:t>, </a:t>
+            </a:r>
+            <a:r>
+              <a:rPr lang="en-US" sz="1200" dirty="0" err="1"/>
+              <a:t>Onivyde</a:t>
+            </a:r>
+            <a:endParaRPr lang="en-US" sz="1200" dirty="0"/>
           </a:p>
           <a:p>
             <a:pPr marL="285750" indent="-285750">
@@ -13584,30 +12332,69 @@
               <a:buChar char="•"/>
             </a:pPr>
             <a:r>
-              <a:rPr lang="en-US" sz="1200" b="1" dirty="0"/>
-              <a:t>2024-2025 shift toward early oncology modalities </a:t>
-            </a:r>
-            <a:r>
               <a:rPr lang="en-US" sz="1200" dirty="0"/>
-              <a:t>(ADCs, T-cell engagers, </a:t>
+              <a:t>Rare Disease emerging as a second growth engine, led by </a:t>
             </a:r>
             <a:r>
               <a:rPr lang="en-US" sz="1200" dirty="0" err="1"/>
-              <a:t>γδ</a:t>
+              <a:t>Iqirvo</a:t>
             </a:r>
             <a:r>
               <a:rPr lang="en-US" sz="1200" dirty="0"/>
-              <a:t> T-cell activation, MAPK pathway assets)</a:t>
+              <a:t> and </a:t>
+            </a:r>
+            <a:r>
+              <a:rPr lang="en-US" sz="1200" dirty="0" err="1"/>
+              <a:t>Bylvay</a:t>
+            </a:r>
+            <a:endParaRPr lang="en-US" sz="1200" dirty="0"/>
+          </a:p>
+          <a:p>
+            <a:pPr marL="285750" indent="-285750">
+              <a:buFont typeface="Arial" panose="020B0604020202020204" pitchFamily="34" charset="0"/>
+              <a:buChar char="•"/>
+            </a:pPr>
+            <a:r>
+              <a:rPr lang="en-US" sz="1200" dirty="0"/>
+              <a:t>Neuroscience anchored by Dysport, with </a:t>
+            </a:r>
+            <a:r>
+              <a:rPr lang="en-US" sz="1200" dirty="0" err="1"/>
+              <a:t>corabotase</a:t>
+            </a:r>
+            <a:r>
+              <a:rPr lang="en-US" sz="1200" dirty="0"/>
+              <a:t> as next-generation growth relay</a:t>
+            </a:r>
+          </a:p>
+          <a:p>
+            <a:pPr marL="285750" indent="-285750">
+              <a:buFont typeface="Arial" panose="020B0604020202020204" pitchFamily="34" charset="0"/>
+              <a:buChar char="•"/>
+            </a:pPr>
+            <a:r>
+              <a:rPr lang="en-US" sz="1200" dirty="0"/>
+              <a:t>Post-2020 external innovation engine: 30+ best-/first-in-class programs added through M&amp;A, licensing and partnerships</a:t>
+            </a:r>
+          </a:p>
+          <a:p>
+            <a:pPr marL="285750" indent="-285750">
+              <a:buFont typeface="Arial" panose="020B0604020202020204" pitchFamily="34" charset="0"/>
+              <a:buChar char="•"/>
+            </a:pPr>
+            <a:r>
+              <a:rPr lang="en-US" sz="1200" dirty="0"/>
+              <a:t>Strategic shift toward precision oncology, rare liver diseases and next-generation neurotoxins</a:t>
             </a:r>
           </a:p>
         </p:txBody>
       </p:sp>
       <p:sp>
         <p:nvSpPr>
-          <p:cNvPr id="20" name="TextBox 19">
+          <p:cNvPr id="22" name="TextBox 21">
             <a:extLst>
               <a:ext uri="{FF2B5EF4-FFF2-40B4-BE49-F238E27FC236}">
-                <a16:creationId xmlns:a16="http://schemas.microsoft.com/office/drawing/2014/main" id="{387E2389-67D0-9DBE-F994-A7F3C3D455DA}"/>
+                <a16:creationId xmlns:a16="http://schemas.microsoft.com/office/drawing/2014/main" id="{FD1D0E5E-3D0B-19EB-58EF-4B8BF5D7C54D}"/>
               </a:ext>
             </a:extLst>
           </p:cNvPr>
@@ -13616,8 +12403,8 @@
         </p:nvSpPr>
         <p:spPr>
           <a:xfrm>
-            <a:off x="7573930" y="4932382"/>
-            <a:ext cx="4448181" cy="276999"/>
+            <a:off x="7292715" y="5116925"/>
+            <a:ext cx="4814082" cy="1569660"/>
           </a:xfrm>
           <a:prstGeom prst="rect">
             <a:avLst/>
@@ -13630,15 +12417,74 @@
           </a:bodyPr>
           <a:lstStyle/>
           <a:p>
-            <a:pPr marL="285750" indent="-285750">
-              <a:buFont typeface="Arial" panose="020B0604020202020204" pitchFamily="34" charset="0"/>
-              <a:buChar char="•"/>
-            </a:pPr>
-            <a:r>
-              <a:rPr lang="fr-FR" sz="1200" b="1" dirty="0"/>
-              <a:t>Reprends </a:t>
-            </a:r>
-            <a:endParaRPr lang="en-AU" sz="1200" dirty="0"/>
+            <a:r>
+              <a:rPr lang="en-US" sz="1200" b="1" dirty="0"/>
+              <a:t>Oncology: </a:t>
+            </a:r>
+            <a:r>
+              <a:rPr lang="en-US" sz="1200" dirty="0"/>
+              <a:t>Can Ipsen offset </a:t>
+            </a:r>
+            <a:r>
+              <a:rPr lang="en-US" sz="1200" dirty="0" err="1"/>
+              <a:t>Somatuline</a:t>
+            </a:r>
+            <a:r>
+              <a:rPr lang="en-US" sz="1200" dirty="0"/>
+              <a:t> LOE risk fast enough through </a:t>
+            </a:r>
+            <a:r>
+              <a:rPr lang="en-US" sz="1200" dirty="0" err="1"/>
+              <a:t>Cabometyx</a:t>
+            </a:r>
+            <a:r>
+              <a:rPr lang="en-US" sz="1200" dirty="0"/>
+              <a:t> / </a:t>
+            </a:r>
+            <a:r>
+              <a:rPr lang="en-US" sz="1200" dirty="0" err="1"/>
+              <a:t>Onivyde</a:t>
+            </a:r>
+            <a:r>
+              <a:rPr lang="en-US" sz="1200" dirty="0"/>
+              <a:t> / </a:t>
+            </a:r>
+            <a:r>
+              <a:rPr lang="en-US" sz="1200" dirty="0" err="1"/>
+              <a:t>Ojemda</a:t>
+            </a:r>
+            <a:r>
+              <a:rPr lang="en-US" sz="1200" dirty="0"/>
+              <a:t> and new precision-oncology modalities?</a:t>
+            </a:r>
+          </a:p>
+          <a:p>
+            <a:r>
+              <a:rPr lang="en-US" sz="1200" b="1" dirty="0"/>
+              <a:t>Rare Disease: </a:t>
+            </a:r>
+            <a:r>
+              <a:rPr lang="en-US" sz="1200" dirty="0"/>
+              <a:t>Is Ipsen building a true second TA pillar, or still using Rare Disease as portfolio diversification?</a:t>
+            </a:r>
+          </a:p>
+          <a:p>
+            <a:r>
+              <a:rPr lang="en-US" sz="1200" b="1" dirty="0"/>
+              <a:t>Neuroscience: </a:t>
+            </a:r>
+            <a:r>
+              <a:rPr lang="en-US" sz="1200" dirty="0"/>
+              <a:t>Is Dysport/</a:t>
+            </a:r>
+            <a:r>
+              <a:rPr lang="en-US" sz="1200" dirty="0" err="1"/>
+              <a:t>corabotase</a:t>
+            </a:r>
+            <a:r>
+              <a:rPr lang="en-US" sz="1200" dirty="0"/>
+              <a:t> enough to secure long-term growth, or does Ipsen need external neuro assets beyond toxin lifecycle expansion?</a:t>
+            </a:r>
           </a:p>
         </p:txBody>
       </p:sp>

</xml_diff>